<commit_message>
fix: deduplicate multiple ExportDocs and align NCR overdue/active metrics with latest PPT tracker
</commit_message>
<xml_diff>
--- a/auto_logs/Open NCRs (updated).pptx
+++ b/auto_logs/Open NCRs (updated).pptx
@@ -309,7 +309,7 @@
           <a:p>
             <a:fld id="{5BCAD085-E8A6-8845-BD4E-CB4CCA059FC4}" type="datetimeFigureOut">
               <a:rPr lang="en-US" smtClean="0"/>
-              <a:t>9/9/26</a:t>
+              <a:t>9/27/26</a:t>
             </a:fld>
             <a:endParaRPr lang="en-US"/>
           </a:p>
@@ -477,7 +477,7 @@
           <a:p>
             <a:fld id="{5BCAD085-E8A6-8845-BD4E-CB4CCA059FC4}" type="datetimeFigureOut">
               <a:rPr lang="en-US" smtClean="0"/>
-              <a:t>9/9/26</a:t>
+              <a:t>9/27/26</a:t>
             </a:fld>
             <a:endParaRPr lang="en-US"/>
           </a:p>
@@ -655,7 +655,7 @@
           <a:p>
             <a:fld id="{5BCAD085-E8A6-8845-BD4E-CB4CCA059FC4}" type="datetimeFigureOut">
               <a:rPr lang="en-US" smtClean="0"/>
-              <a:t>9/9/26</a:t>
+              <a:t>9/27/26</a:t>
             </a:fld>
             <a:endParaRPr lang="en-US"/>
           </a:p>
@@ -823,7 +823,7 @@
           <a:p>
             <a:fld id="{5BCAD085-E8A6-8845-BD4E-CB4CCA059FC4}" type="datetimeFigureOut">
               <a:rPr lang="en-US" smtClean="0"/>
-              <a:t>9/9/26</a:t>
+              <a:t>9/27/26</a:t>
             </a:fld>
             <a:endParaRPr lang="en-US"/>
           </a:p>
@@ -1068,7 +1068,7 @@
           <a:p>
             <a:fld id="{5BCAD085-E8A6-8845-BD4E-CB4CCA059FC4}" type="datetimeFigureOut">
               <a:rPr lang="en-US" smtClean="0"/>
-              <a:t>9/9/26</a:t>
+              <a:t>9/27/26</a:t>
             </a:fld>
             <a:endParaRPr lang="en-US"/>
           </a:p>
@@ -1353,7 +1353,7 @@
           <a:p>
             <a:fld id="{5BCAD085-E8A6-8845-BD4E-CB4CCA059FC4}" type="datetimeFigureOut">
               <a:rPr lang="en-US" smtClean="0"/>
-              <a:t>9/9/26</a:t>
+              <a:t>9/27/26</a:t>
             </a:fld>
             <a:endParaRPr lang="en-US"/>
           </a:p>
@@ -1772,7 +1772,7 @@
           <a:p>
             <a:fld id="{5BCAD085-E8A6-8845-BD4E-CB4CCA059FC4}" type="datetimeFigureOut">
               <a:rPr lang="en-US" smtClean="0"/>
-              <a:t>9/9/26</a:t>
+              <a:t>9/27/26</a:t>
             </a:fld>
             <a:endParaRPr lang="en-US"/>
           </a:p>
@@ -1889,7 +1889,7 @@
           <a:p>
             <a:fld id="{5BCAD085-E8A6-8845-BD4E-CB4CCA059FC4}" type="datetimeFigureOut">
               <a:rPr lang="en-US" smtClean="0"/>
-              <a:t>9/9/26</a:t>
+              <a:t>9/27/26</a:t>
             </a:fld>
             <a:endParaRPr lang="en-US"/>
           </a:p>
@@ -1984,7 +1984,7 @@
           <a:p>
             <a:fld id="{5BCAD085-E8A6-8845-BD4E-CB4CCA059FC4}" type="datetimeFigureOut">
               <a:rPr lang="en-US" smtClean="0"/>
-              <a:t>9/9/26</a:t>
+              <a:t>9/27/26</a:t>
             </a:fld>
             <a:endParaRPr lang="en-US"/>
           </a:p>
@@ -2259,7 +2259,7 @@
           <a:p>
             <a:fld id="{5BCAD085-E8A6-8845-BD4E-CB4CCA059FC4}" type="datetimeFigureOut">
               <a:rPr lang="en-US" smtClean="0"/>
-              <a:t>9/9/26</a:t>
+              <a:t>9/27/26</a:t>
             </a:fld>
             <a:endParaRPr lang="en-US"/>
           </a:p>
@@ -2511,7 +2511,7 @@
           <a:p>
             <a:fld id="{5BCAD085-E8A6-8845-BD4E-CB4CCA059FC4}" type="datetimeFigureOut">
               <a:rPr lang="en-US" smtClean="0"/>
-              <a:t>9/9/26</a:t>
+              <a:t>9/27/26</a:t>
             </a:fld>
             <a:endParaRPr lang="en-US"/>
           </a:p>
@@ -2722,7 +2722,7 @@
           <a:p>
             <a:fld id="{5BCAD085-E8A6-8845-BD4E-CB4CCA059FC4}" type="datetimeFigureOut">
               <a:rPr lang="en-US" smtClean="0"/>
-              <a:t>9/9/26</a:t>
+              <a:t>9/27/26</a:t>
             </a:fld>
             <a:endParaRPr lang="en-US"/>
           </a:p>
@@ -3150,7 +3150,7 @@
           <p:nvPr>
             <p:extLst>
               <p:ext uri="{D42A27DB-BD31-4B8C-83A1-F6EECF244321}">
-                <p14:modId xmlns:p14="http://schemas.microsoft.com/office/powerpoint/2010/main" val="1822726700"/>
+                <p14:modId xmlns:p14="http://schemas.microsoft.com/office/powerpoint/2010/main" val="3730350599"/>
               </p:ext>
             </p:extLst>
           </p:nvPr>
@@ -3406,8 +3406,121 @@
                         </a:defRPr>
                       </a:pPr>
                       <a:r>
+                        <a:t>1</a:t>
+                      </a:r>
+                    </a:p>
+                  </a:txBody>
+                  <a:tcPr anchor="ctr">
+                    <a:solidFill>
+                      <a:srgbClr val="FFFFFF"/>
+                    </a:solidFill>
+                  </a:tcPr>
+                </a:tc>
+                <a:tc>
+                  <a:txBody>
+                    <a:bodyPr/>
+                    <a:lstStyle/>
+                    <a:p>
+                      <a:pPr>
+                        <a:defRPr sz="1400" b="1">
+                          <a:solidFill>
+                            <a:srgbClr val="0F2444"/>
+                          </a:solidFill>
+                          <a:latin typeface="Calibri"/>
+                        </a:defRPr>
+                      </a:pPr>
+                      <a:r>
+                        <a:t>BV-BSW-105-0000-</a:t>
+                      </a:r>
+                      <a:br/>
+                      <a:r>
+                        <a:t>SOA-NCR-QL-000016</a:t>
+                      </a:r>
+                    </a:p>
+                    <a:p>
+                      <a:pPr>
+                        <a:defRPr sz="1400" b="1">
+                          <a:solidFill>
+                            <a:srgbClr val="B45309"/>
+                          </a:solidFill>
+                          <a:latin typeface="Calibri"/>
+                        </a:defRPr>
+                      </a:pPr>
+                      <a:r>
+                        <a:t>Civil (Zone A – B2 Soffit)</a:t>
+                      </a:r>
+                    </a:p>
+                  </a:txBody>
+                  <a:tcPr anchor="ctr">
+                    <a:solidFill>
+                      <a:srgbClr val="FFFFFF"/>
+                    </a:solidFill>
+                  </a:tcPr>
+                </a:tc>
+                <a:tc>
+                  <a:txBody>
+                    <a:bodyPr/>
+                    <a:lstStyle/>
+                    <a:p>
+                      <a:pPr>
+                        <a:defRPr sz="1400">
+                          <a:solidFill>
+                            <a:srgbClr val="0F172A"/>
+                          </a:solidFill>
+                          <a:latin typeface="Calibri"/>
+                        </a:defRPr>
+                      </a:pPr>
+                      <a:r>
+                        <a:t>Substandard SF3 concrete soffit finish: recurring honeycombing, surface voids, uneven texture, embedded tape/wood.</a:t>
+                      </a:r>
+                    </a:p>
+                  </a:txBody>
+                  <a:tcPr anchor="ctr">
+                    <a:solidFill>
+                      <a:srgbClr val="FFFFFF"/>
+                    </a:solidFill>
+                  </a:tcPr>
+                </a:tc>
+                <a:tc>
+                  <a:txBody>
+                    <a:bodyPr/>
+                    <a:lstStyle/>
+                    <a:p>
+                      <a:pPr>
+                        <a:defRPr sz="1400">
+                          <a:solidFill>
+                            <a:srgbClr val="0F172A"/>
+                          </a:solidFill>
+                          <a:latin typeface="Calibri"/>
+                        </a:defRPr>
+                      </a:pPr>
+                      <a:r>
+                        <a:t>Submit separate SF-3.0 repair Method Statement; initiate trial repair mock-up using approved repair materials.</a:t>
+                      </a:r>
+                    </a:p>
+                  </a:txBody>
+                  <a:tcPr anchor="ctr">
+                    <a:solidFill>
+                      <a:srgbClr val="FFFFFF"/>
+                    </a:solidFill>
+                  </a:tcPr>
+                </a:tc>
+                <a:tc>
+                  <a:txBody>
+                    <a:bodyPr/>
+                    <a:lstStyle/>
+                    <a:p>
+                      <a:pPr algn="ctr">
+                        <a:defRPr sz="1400" b="1">
+                          <a:solidFill>
+                            <a:srgbClr val="0F172A"/>
+                          </a:solidFill>
+                          <a:latin typeface="Calibri"/>
+                        </a:defRPr>
+                      </a:pPr>
+                      <a:r>
                         <a:rPr dirty="0"/>
-                        <a:t>1</a:t>
+                        <a:t>2026-02-17</a:t>
                       </a:r>
                     </a:p>
                   </a:txBody>
@@ -3422,33 +3535,39 @@
                     <a:bodyPr/>
                     <a:lstStyle/>
                     <a:p>
-                      <a:pPr>
-                        <a:defRPr sz="1400" b="1">
-                          <a:solidFill>
-                            <a:srgbClr val="0F2444"/>
-                          </a:solidFill>
-                          <a:latin typeface="Calibri"/>
-                        </a:defRPr>
-                      </a:pPr>
-                      <a:r>
-                        <a:t>BV-BSW-105-0000-</a:t>
-                      </a:r>
-                      <a:br/>
-                      <a:r>
-                        <a:t>SOA-NCR-QL-000016</a:t>
-                      </a:r>
-                    </a:p>
-                    <a:p>
-                      <a:pPr>
-                        <a:defRPr sz="1400" b="1">
-                          <a:solidFill>
-                            <a:srgbClr val="B45309"/>
-                          </a:solidFill>
-                          <a:latin typeface="Calibri"/>
-                        </a:defRPr>
-                      </a:pPr>
-                      <a:r>
-                        <a:t>Civil (Zone A – B2 Soffit)</a:t>
+                      <a:pPr algn="ctr">
+                        <a:defRPr sz="2200" b="1">
+                          <a:solidFill>
+                            <a:srgbClr val="B91C1C"/>
+                          </a:solidFill>
+                          <a:latin typeface="Calibri"/>
+                        </a:defRPr>
+                      </a:pPr>
+                      <a:r>
+                        <a:rPr dirty="0"/>
+                        <a:t>2</a:t>
+                      </a:r>
+                      <a:r>
+                        <a:rPr lang="en-US" dirty="0"/>
+                        <a:t>22</a:t>
+                      </a:r>
+                      <a:r>
+                        <a:rPr dirty="0"/>
+                        <a:t> d</a:t>
+                      </a:r>
+                    </a:p>
+                    <a:p>
+                      <a:pPr algn="ctr">
+                        <a:defRPr sz="1400" b="1">
+                          <a:solidFill>
+                            <a:srgbClr val="B91C1C"/>
+                          </a:solidFill>
+                          <a:latin typeface="Calibri"/>
+                        </a:defRPr>
+                      </a:pPr>
+                      <a:r>
+                        <a:rPr dirty="0"/>
+                        <a:t>[OVERDUE]</a:t>
                       </a:r>
                     </a:p>
                   </a:txBody>
@@ -3472,117 +3591,18 @@
                         </a:defRPr>
                       </a:pPr>
                       <a:r>
-                        <a:t>Substandard SF3 concrete soffit finish: recurring honeycombing, surface voids, uneven texture, embedded tape/wood.</a:t>
-                      </a:r>
-                    </a:p>
-                  </a:txBody>
-                  <a:tcPr anchor="ctr">
-                    <a:solidFill>
-                      <a:srgbClr val="FFFFFF"/>
-                    </a:solidFill>
-                  </a:tcPr>
-                </a:tc>
-                <a:tc>
-                  <a:txBody>
-                    <a:bodyPr/>
-                    <a:lstStyle/>
-                    <a:p>
-                      <a:pPr>
-                        <a:defRPr sz="1400">
-                          <a:solidFill>
-                            <a:srgbClr val="0F172A"/>
-                          </a:solidFill>
-                          <a:latin typeface="Calibri"/>
-                        </a:defRPr>
-                      </a:pPr>
-                      <a:r>
-                        <a:t>Submit separate SF-3.0 repair Method Statement; initiate trial repair mock-up using approved repair materials.</a:t>
-                      </a:r>
-                    </a:p>
-                  </a:txBody>
-                  <a:tcPr anchor="ctr">
-                    <a:solidFill>
-                      <a:srgbClr val="FFFFFF"/>
-                    </a:solidFill>
-                  </a:tcPr>
-                </a:tc>
-                <a:tc>
-                  <a:txBody>
-                    <a:bodyPr/>
-                    <a:lstStyle/>
-                    <a:p>
-                      <a:pPr algn="ctr">
-                        <a:defRPr sz="1400" b="1">
-                          <a:solidFill>
-                            <a:srgbClr val="0F172A"/>
-                          </a:solidFill>
-                          <a:latin typeface="Calibri"/>
-                        </a:defRPr>
-                      </a:pPr>
-                      <a:r>
-                        <a:t>2026-02-17</a:t>
-                      </a:r>
-                    </a:p>
-                  </a:txBody>
-                  <a:tcPr anchor="ctr">
-                    <a:solidFill>
-                      <a:srgbClr val="FFFFFF"/>
-                    </a:solidFill>
-                  </a:tcPr>
-                </a:tc>
-                <a:tc>
-                  <a:txBody>
-                    <a:bodyPr/>
-                    <a:lstStyle/>
-                    <a:p>
-                      <a:pPr algn="ctr">
-                        <a:defRPr sz="2200" b="1">
-                          <a:solidFill>
-                            <a:srgbClr val="B91C1C"/>
-                          </a:solidFill>
-                          <a:latin typeface="Calibri"/>
-                        </a:defRPr>
-                      </a:pPr>
-                      <a:r>
-                        <a:t>202 d</a:t>
-                      </a:r>
-                    </a:p>
-                    <a:p>
-                      <a:pPr algn="ctr">
-                        <a:defRPr sz="1400" b="1">
-                          <a:solidFill>
-                            <a:srgbClr val="B91C1C"/>
-                          </a:solidFill>
-                          <a:latin typeface="Calibri"/>
-                        </a:defRPr>
-                      </a:pPr>
-                      <a:r>
-                        <a:t>[OVERDUE]</a:t>
-                      </a:r>
-                    </a:p>
-                  </a:txBody>
-                  <a:tcPr anchor="ctr">
-                    <a:solidFill>
-                      <a:srgbClr val="FFFFFF"/>
-                    </a:solidFill>
-                  </a:tcPr>
-                </a:tc>
-                <a:tc>
-                  <a:txBody>
-                    <a:bodyPr/>
-                    <a:lstStyle/>
-                    <a:p>
-                      <a:pPr>
-                        <a:defRPr sz="1400">
-                          <a:solidFill>
-                            <a:srgbClr val="0F172A"/>
-                          </a:solidFill>
-                          <a:latin typeface="Calibri"/>
-                        </a:defRPr>
-                      </a:pPr>
-                      <a:r>
-                        <a:t>MST for SF2 &amp; SF3 has been submitted</a:t>
-                      </a:r>
+                        <a:rPr lang="en-US" dirty="0"/>
+                        <a:t>Mockup inspection for sofit to be done by 30</a:t>
+                      </a:r>
+                      <a:r>
+                        <a:rPr lang="en-US" baseline="30000" dirty="0"/>
+                        <a:t>th</a:t>
+                      </a:r>
+                      <a:r>
+                        <a:rPr lang="en-US" dirty="0"/>
+                        <a:t> Sep, once mock-up is approved other areas plan will be provided.</a:t>
+                      </a:r>
+                      <a:endParaRPr dirty="0"/>
                     </a:p>
                   </a:txBody>
                   <a:tcPr anchor="ctr">
@@ -3725,6 +3745,7 @@
                         </a:defRPr>
                       </a:pPr>
                       <a:r>
+                        <a:rPr dirty="0"/>
                         <a:t>2026-04-28</a:t>
                       </a:r>
                     </a:p>
@@ -3749,7 +3770,16 @@
                         </a:defRPr>
                       </a:pPr>
                       <a:r>
-                        <a:t>132 d</a:t>
+                        <a:rPr dirty="0"/>
+                        <a:t>1</a:t>
+                      </a:r>
+                      <a:r>
+                        <a:rPr lang="en-US" dirty="0"/>
+                        <a:t>52</a:t>
+                      </a:r>
+                      <a:r>
+                        <a:rPr dirty="0"/>
+                        <a:t> d</a:t>
                       </a:r>
                     </a:p>
                     <a:p>
@@ -3762,6 +3792,7 @@
                         </a:defRPr>
                       </a:pPr>
                       <a:r>
+                        <a:rPr dirty="0"/>
                         <a:t>[OVERDUE]</a:t>
                       </a:r>
                     </a:p>
@@ -3786,22 +3817,26 @@
                         </a:defRPr>
                       </a:pPr>
                       <a:r>
-                        <a:rPr dirty="0"/>
-                        <a:t>NDT testing conducted</a:t>
-                      </a:r>
-                      <a:r>
-                        <a:rPr lang="en-US" dirty="0"/>
-                        <a:t>. The report is expected by Monday 14</a:t>
-                      </a:r>
-                      <a:r>
-                        <a:rPr lang="en-US" baseline="30000" dirty="0"/>
-                        <a:t>th</a:t>
-                      </a:r>
-                      <a:r>
-                        <a:rPr lang="en-US" dirty="0"/>
-                        <a:t> Sep</a:t>
-                      </a:r>
-                      <a:endParaRPr dirty="0"/>
+                        <a:rPr sz="1400" dirty="0">
+                          <a:solidFill>
+                            <a:schemeClr val="tx1"/>
+                          </a:solidFill>
+                        </a:rPr>
+                        <a:t>NDT testing conducted. The test is passed</a:t>
+                      </a:r>
+                      <a:r>
+                        <a:rPr lang="en-US" sz="1400" dirty="0">
+                          <a:solidFill>
+                            <a:schemeClr val="tx1"/>
+                          </a:solidFill>
+                        </a:rPr>
+                        <a:t>, the report has been submitted on Aconex</a:t>
+                      </a:r>
+                      <a:endParaRPr sz="1400" dirty="0">
+                        <a:solidFill>
+                          <a:schemeClr val="tx1"/>
+                        </a:solidFill>
+                      </a:endParaRPr>
                     </a:p>
                   </a:txBody>
                   <a:tcPr anchor="ctr">
@@ -3944,6 +3979,7 @@
                         </a:defRPr>
                       </a:pPr>
                       <a:r>
+                        <a:rPr dirty="0"/>
                         <a:t>2026-05-24</a:t>
                       </a:r>
                     </a:p>
@@ -3968,7 +4004,16 @@
                         </a:defRPr>
                       </a:pPr>
                       <a:r>
-                        <a:t>106 d</a:t>
+                        <a:rPr dirty="0"/>
+                        <a:t>1</a:t>
+                      </a:r>
+                      <a:r>
+                        <a:rPr lang="en-US" dirty="0"/>
+                        <a:t>26</a:t>
+                      </a:r>
+                      <a:r>
+                        <a:rPr dirty="0"/>
+                        <a:t> d</a:t>
                       </a:r>
                     </a:p>
                     <a:p>
@@ -3981,6 +4026,7 @@
                         </a:defRPr>
                       </a:pPr>
                       <a:r>
+                        <a:rPr dirty="0"/>
                         <a:t>[OVERDUE]</a:t>
                       </a:r>
                     </a:p>
@@ -4005,12 +4051,16 @@
                         </a:defRPr>
                       </a:pPr>
                       <a:r>
-                        <a:rPr dirty="0"/>
-                        <a:t>3rd-party testing not available, we are in contact with manufacturer for solution</a:t>
-                      </a:r>
-                      <a:r>
                         <a:rPr lang="en-US" dirty="0"/>
-                        <a:t>, letter is expected by next week</a:t>
+                        <a:t>The letter has been submitted to CSC for review on 27</a:t>
+                      </a:r>
+                      <a:r>
+                        <a:rPr lang="en-US" baseline="30000" dirty="0"/>
+                        <a:t>th</a:t>
+                      </a:r>
+                      <a:r>
+                        <a:rPr lang="en-US" dirty="0"/>
+                        <a:t> Sep</a:t>
                       </a:r>
                       <a:endParaRPr dirty="0"/>
                     </a:p>
@@ -4109,14 +4159,14 @@
           <p:nvPr>
             <p:extLst>
               <p:ext uri="{D42A27DB-BD31-4B8C-83A1-F6EECF244321}">
-                <p14:modId xmlns:p14="http://schemas.microsoft.com/office/powerpoint/2010/main" val="2135938511"/>
+                <p14:modId xmlns:p14="http://schemas.microsoft.com/office/powerpoint/2010/main" val="4222827565"/>
               </p:ext>
             </p:extLst>
           </p:nvPr>
         </p:nvGraphicFramePr>
         <p:xfrm>
-          <a:off x="98475" y="76200"/>
-          <a:ext cx="11844998" cy="6605953"/>
+          <a:off x="240384" y="76201"/>
+          <a:ext cx="11277295" cy="6141717"/>
         </p:xfrm>
         <a:graphic>
           <a:graphicData uri="http://schemas.openxmlformats.org/drawingml/2006/table">
@@ -4125,49 +4175,49 @@
                 <a:tableStyleId>{5C22544A-7EE6-4342-B048-85BDC9FD1C3A}</a:tableStyleId>
               </a:tblPr>
               <a:tblGrid>
-                <a:gridCol w="528237">
+                <a:gridCol w="502920">
                   <a:extLst>
                     <a:ext uri="{9D8B030D-6E8A-4147-A177-3AD203B41FA5}">
                       <a16:colId xmlns:a16="http://schemas.microsoft.com/office/drawing/2014/main" val="20000"/>
                     </a:ext>
                   </a:extLst>
                 </a:gridCol>
-                <a:gridCol w="2112949">
+                <a:gridCol w="2011680">
                   <a:extLst>
                     <a:ext uri="{9D8B030D-6E8A-4147-A177-3AD203B41FA5}">
                       <a16:colId xmlns:a16="http://schemas.microsoft.com/office/drawing/2014/main" val="20001"/>
                     </a:ext>
                   </a:extLst>
                 </a:gridCol>
-                <a:gridCol w="2689207">
+                <a:gridCol w="2560320">
                   <a:extLst>
                     <a:ext uri="{9D8B030D-6E8A-4147-A177-3AD203B41FA5}">
                       <a16:colId xmlns:a16="http://schemas.microsoft.com/office/drawing/2014/main" val="20002"/>
                     </a:ext>
                   </a:extLst>
                 </a:gridCol>
-                <a:gridCol w="2593164">
+                <a:gridCol w="2468880">
                   <a:extLst>
                     <a:ext uri="{9D8B030D-6E8A-4147-A177-3AD203B41FA5}">
                       <a16:colId xmlns:a16="http://schemas.microsoft.com/office/drawing/2014/main" val="20003"/>
                     </a:ext>
                   </a:extLst>
                 </a:gridCol>
-                <a:gridCol w="1056474">
+                <a:gridCol w="1005840">
                   <a:extLst>
                     <a:ext uri="{9D8B030D-6E8A-4147-A177-3AD203B41FA5}">
                       <a16:colId xmlns:a16="http://schemas.microsoft.com/office/drawing/2014/main" val="20004"/>
                     </a:ext>
                   </a:extLst>
                 </a:gridCol>
-                <a:gridCol w="1104496">
+                <a:gridCol w="1051560">
                   <a:extLst>
                     <a:ext uri="{9D8B030D-6E8A-4147-A177-3AD203B41FA5}">
                       <a16:colId xmlns:a16="http://schemas.microsoft.com/office/drawing/2014/main" val="20005"/>
                     </a:ext>
                   </a:extLst>
                 </a:gridCol>
-                <a:gridCol w="1760471">
+                <a:gridCol w="1676095">
                   <a:extLst>
                     <a:ext uri="{9D8B030D-6E8A-4147-A177-3AD203B41FA5}">
                       <a16:colId xmlns:a16="http://schemas.microsoft.com/office/drawing/2014/main" val="20006"/>
@@ -4175,7 +4225,7 @@
                   </a:extLst>
                 </a:gridCol>
               </a:tblGrid>
-              <a:tr h="399017">
+              <a:tr h="384048">
                 <a:tc>
                   <a:txBody>
                     <a:bodyPr/>
@@ -4350,7 +4400,7 @@
                   </a:ext>
                 </a:extLst>
               </a:tr>
-              <a:tr h="2311768">
+              <a:tr h="1874519">
                 <a:tc>
                   <a:txBody>
                     <a:bodyPr/>
@@ -4430,6 +4480,7 @@
                         </a:defRPr>
                       </a:pPr>
                       <a:r>
+                        <a:rPr dirty="0"/>
                         <a:t>Unauthorized blockwork construction above lintel beam level without approved builder drawings or MEP clearance.</a:t>
                       </a:r>
                     </a:p>
@@ -4454,8 +4505,74 @@
                         </a:defRPr>
                       </a:pPr>
                       <a:r>
+                        <a:t>Submitted revised elevation drawings (WF-216178) conforming to calculations (WF-200995); coordinate MEP before casting.</a:t>
+                      </a:r>
+                    </a:p>
+                  </a:txBody>
+                  <a:tcPr anchor="ctr">
+                    <a:solidFill>
+                      <a:srgbClr val="FFFFFF"/>
+                    </a:solidFill>
+                  </a:tcPr>
+                </a:tc>
+                <a:tc>
+                  <a:txBody>
+                    <a:bodyPr/>
+                    <a:lstStyle/>
+                    <a:p>
+                      <a:pPr algn="ctr">
+                        <a:defRPr sz="1400" b="1">
+                          <a:solidFill>
+                            <a:srgbClr val="0F172A"/>
+                          </a:solidFill>
+                          <a:latin typeface="Calibri"/>
+                        </a:defRPr>
+                      </a:pPr>
+                      <a:r>
+                        <a:t>2026-06-28</a:t>
+                      </a:r>
+                    </a:p>
+                  </a:txBody>
+                  <a:tcPr anchor="ctr">
+                    <a:solidFill>
+                      <a:srgbClr val="FFFFFF"/>
+                    </a:solidFill>
+                  </a:tcPr>
+                </a:tc>
+                <a:tc>
+                  <a:txBody>
+                    <a:bodyPr/>
+                    <a:lstStyle/>
+                    <a:p>
+                      <a:pPr algn="ctr">
+                        <a:defRPr sz="2200" b="1">
+                          <a:solidFill>
+                            <a:srgbClr val="B91C1C"/>
+                          </a:solidFill>
+                          <a:latin typeface="Calibri"/>
+                        </a:defRPr>
+                      </a:pPr>
+                      <a:r>
+                        <a:rPr lang="en-US" dirty="0"/>
+                        <a:t>91</a:t>
+                      </a:r>
+                      <a:r>
                         <a:rPr dirty="0"/>
-                        <a:t>Submitted revised elevation drawings (WF-216178) conforming to calculations (WF-200995); coordinate MEP before casting.</a:t>
+                        <a:t> d</a:t>
+                      </a:r>
+                    </a:p>
+                    <a:p>
+                      <a:pPr algn="ctr">
+                        <a:defRPr sz="1400" b="1">
+                          <a:solidFill>
+                            <a:srgbClr val="B91C1C"/>
+                          </a:solidFill>
+                          <a:latin typeface="Calibri"/>
+                        </a:defRPr>
+                      </a:pPr>
+                      <a:r>
+                        <a:rPr dirty="0"/>
+                        <a:t>[OVERDUE]</a:t>
                       </a:r>
                     </a:p>
                   </a:txBody>
@@ -4470,67 +4587,6 @@
                     <a:bodyPr/>
                     <a:lstStyle/>
                     <a:p>
-                      <a:pPr algn="ctr">
-                        <a:defRPr sz="1400" b="1">
-                          <a:solidFill>
-                            <a:srgbClr val="0F172A"/>
-                          </a:solidFill>
-                          <a:latin typeface="Calibri"/>
-                        </a:defRPr>
-                      </a:pPr>
-                      <a:r>
-                        <a:t>2026-06-28</a:t>
-                      </a:r>
-                    </a:p>
-                  </a:txBody>
-                  <a:tcPr anchor="ctr">
-                    <a:solidFill>
-                      <a:srgbClr val="FFFFFF"/>
-                    </a:solidFill>
-                  </a:tcPr>
-                </a:tc>
-                <a:tc>
-                  <a:txBody>
-                    <a:bodyPr/>
-                    <a:lstStyle/>
-                    <a:p>
-                      <a:pPr algn="ctr">
-                        <a:defRPr sz="2200" b="1">
-                          <a:solidFill>
-                            <a:srgbClr val="B91C1C"/>
-                          </a:solidFill>
-                          <a:latin typeface="Calibri"/>
-                        </a:defRPr>
-                      </a:pPr>
-                      <a:r>
-                        <a:t>71 d</a:t>
-                      </a:r>
-                    </a:p>
-                    <a:p>
-                      <a:pPr algn="ctr">
-                        <a:defRPr sz="1400" b="1">
-                          <a:solidFill>
-                            <a:srgbClr val="B91C1C"/>
-                          </a:solidFill>
-                          <a:latin typeface="Calibri"/>
-                        </a:defRPr>
-                      </a:pPr>
-                      <a:r>
-                        <a:t>[OVERDUE]</a:t>
-                      </a:r>
-                    </a:p>
-                  </a:txBody>
-                  <a:tcPr anchor="ctr">
-                    <a:solidFill>
-                      <a:srgbClr val="FFFFFF"/>
-                    </a:solidFill>
-                  </a:tcPr>
-                </a:tc>
-                <a:tc>
-                  <a:txBody>
-                    <a:bodyPr/>
-                    <a:lstStyle/>
-                    <a:p>
                       <a:pPr>
                         <a:defRPr sz="1400">
                           <a:solidFill>
@@ -4540,9 +4596,18 @@
                         </a:defRPr>
                       </a:pPr>
                       <a:r>
-                        <a:rPr dirty="0"/>
-                        <a:t>Drawings are code C due to room ID/Name, MEP is code B. MEP dept is actively working with Arch before casting takes place. Bond beam levels will be reflected in the As-built drawings.</a:t>
-                      </a:r>
+                        <a:rPr lang="en-US" dirty="0"/>
+                        <a:t>Meeting with CSC to discuss Arch issues is schedule on 28</a:t>
+                      </a:r>
+                      <a:r>
+                        <a:rPr lang="en-US" baseline="30000" dirty="0"/>
+                        <a:t>th</a:t>
+                      </a:r>
+                      <a:r>
+                        <a:rPr lang="en-US" dirty="0"/>
+                        <a:t> Sep at 10 AM.</a:t>
+                      </a:r>
+                      <a:endParaRPr dirty="0"/>
                     </a:p>
                   </a:txBody>
                   <a:tcPr anchor="ctr">
@@ -4557,7 +4622,7 @@
                   </a:ext>
                 </a:extLst>
               </a:tr>
-              <a:tr h="1947584">
+              <a:tr h="1874519">
                 <a:tc>
                   <a:txBody>
                     <a:bodyPr/>
@@ -4596,29 +4661,140 @@
                         </a:defRPr>
                       </a:pPr>
                       <a:r>
+                        <a:t>BV-BSW-105-0000-</a:t>
+                      </a:r>
+                      <a:br/>
+                      <a:r>
+                        <a:t>SOA-NCR-QL-000028</a:t>
+                      </a:r>
+                    </a:p>
+                    <a:p>
+                      <a:pPr>
+                        <a:defRPr sz="1400" b="1">
+                          <a:solidFill>
+                            <a:srgbClr val="B45309"/>
+                          </a:solidFill>
+                          <a:latin typeface="Calibri"/>
+                        </a:defRPr>
+                      </a:pPr>
+                      <a:r>
+                        <a:t>Civil (Zone 5 L0 to L1)</a:t>
+                      </a:r>
+                    </a:p>
+                  </a:txBody>
+                  <a:tcPr anchor="ctr">
+                    <a:solidFill>
+                      <a:srgbClr val="F8FAFC"/>
+                    </a:solidFill>
+                  </a:tcPr>
+                </a:tc>
+                <a:tc>
+                  <a:txBody>
+                    <a:bodyPr/>
+                    <a:lstStyle/>
+                    <a:p>
+                      <a:pPr>
+                        <a:defRPr sz="1400">
+                          <a:solidFill>
+                            <a:srgbClr val="0F172A"/>
+                          </a:solidFill>
+                          <a:latin typeface="Calibri"/>
+                        </a:defRPr>
+                      </a:pPr>
+                      <a:r>
                         <a:rPr dirty="0"/>
-                        <a:t>BV-BSW-105-0000-</a:t>
-                      </a:r>
-                      <a:br>
+                        <a:t>ACROW clearance issued without verification, causing fresh concrete slurry leak into B2 elevator shaft.</a:t>
+                      </a:r>
+                    </a:p>
+                  </a:txBody>
+                  <a:tcPr anchor="ctr">
+                    <a:solidFill>
+                      <a:srgbClr val="F8FAFC"/>
+                    </a:solidFill>
+                  </a:tcPr>
+                </a:tc>
+                <a:tc>
+                  <a:txBody>
+                    <a:bodyPr/>
+                    <a:lstStyle/>
+                    <a:p>
+                      <a:pPr>
+                        <a:defRPr sz="1400">
+                          <a:solidFill>
+                            <a:srgbClr val="0F172A"/>
+                          </a:solidFill>
+                          <a:latin typeface="Calibri"/>
+                        </a:defRPr>
+                      </a:pPr>
+                      <a:r>
+                        <a:t>Enforce strict ACROW pre-pour physical site checks; seal formwork joints; clean elevator shaft; submit formal CAPA.</a:t>
+                      </a:r>
+                    </a:p>
+                  </a:txBody>
+                  <a:tcPr anchor="ctr">
+                    <a:solidFill>
+                      <a:srgbClr val="F8FAFC"/>
+                    </a:solidFill>
+                  </a:tcPr>
+                </a:tc>
+                <a:tc>
+                  <a:txBody>
+                    <a:bodyPr/>
+                    <a:lstStyle/>
+                    <a:p>
+                      <a:pPr algn="ctr">
+                        <a:defRPr sz="1400" b="1">
+                          <a:solidFill>
+                            <a:srgbClr val="0F172A"/>
+                          </a:solidFill>
+                          <a:latin typeface="Calibri"/>
+                        </a:defRPr>
+                      </a:pPr>
+                      <a:r>
+                        <a:t>2026-07-12</a:t>
+                      </a:r>
+                    </a:p>
+                  </a:txBody>
+                  <a:tcPr anchor="ctr">
+                    <a:solidFill>
+                      <a:srgbClr val="F8FAFC"/>
+                    </a:solidFill>
+                  </a:tcPr>
+                </a:tc>
+                <a:tc>
+                  <a:txBody>
+                    <a:bodyPr/>
+                    <a:lstStyle/>
+                    <a:p>
+                      <a:pPr algn="ctr">
+                        <a:defRPr sz="2200" b="1">
+                          <a:solidFill>
+                            <a:srgbClr val="B91C1C"/>
+                          </a:solidFill>
+                          <a:latin typeface="Calibri"/>
+                        </a:defRPr>
+                      </a:pPr>
+                      <a:r>
+                        <a:rPr lang="en-US" dirty="0"/>
+                        <a:t>77</a:t>
+                      </a:r>
+                      <a:r>
                         <a:rPr dirty="0"/>
-                      </a:br>
+                        <a:t> d</a:t>
+                      </a:r>
+                    </a:p>
+                    <a:p>
+                      <a:pPr algn="ctr">
+                        <a:defRPr sz="1400" b="1">
+                          <a:solidFill>
+                            <a:srgbClr val="B91C1C"/>
+                          </a:solidFill>
+                          <a:latin typeface="Calibri"/>
+                        </a:defRPr>
+                      </a:pPr>
                       <a:r>
                         <a:rPr dirty="0"/>
-                        <a:t>SOA-NCR-QL-000027</a:t>
-                      </a:r>
-                    </a:p>
-                    <a:p>
-                      <a:pPr>
-                        <a:defRPr sz="1400" b="1">
-                          <a:solidFill>
-                            <a:srgbClr val="B45309"/>
-                          </a:solidFill>
-                          <a:latin typeface="Calibri"/>
-                        </a:defRPr>
-                      </a:pPr>
-                      <a:r>
-                        <a:rPr dirty="0"/>
-                        <a:t>Arch / Civil (Zone E – B1 Wall)</a:t>
+                        <a:t>[OVERDUE]</a:t>
                       </a:r>
                     </a:p>
                   </a:txBody>
@@ -4642,127 +4818,23 @@
                         </a:defRPr>
                       </a:pPr>
                       <a:r>
-                        <a:rPr dirty="0"/>
-                        <a:t>Graffiti on SF-3.0 exposed concrete wall at Zone E (B1 level), compromising architectural fair-faced finish.</a:t>
-                      </a:r>
-                    </a:p>
-                  </a:txBody>
-                  <a:tcPr anchor="ctr">
-                    <a:solidFill>
-                      <a:srgbClr val="F8FAFC"/>
-                    </a:solidFill>
-                  </a:tcPr>
-                </a:tc>
-                <a:tc>
-                  <a:txBody>
-                    <a:bodyPr/>
-                    <a:lstStyle/>
-                    <a:p>
-                      <a:pPr>
-                        <a:defRPr sz="1400">
-                          <a:solidFill>
-                            <a:srgbClr val="0F172A"/>
-                          </a:solidFill>
-                          <a:latin typeface="Calibri"/>
-                        </a:defRPr>
-                      </a:pPr>
-                      <a:r>
-                        <a:t>Remove graffiti via gentle sanding/washing to match color; submit SF3 repair MS/WIR; post warning signage &amp; hold TBT.</a:t>
-                      </a:r>
-                    </a:p>
-                  </a:txBody>
-                  <a:tcPr anchor="ctr">
-                    <a:solidFill>
-                      <a:srgbClr val="F8FAFC"/>
-                    </a:solidFill>
-                  </a:tcPr>
-                </a:tc>
-                <a:tc>
-                  <a:txBody>
-                    <a:bodyPr/>
-                    <a:lstStyle/>
-                    <a:p>
-                      <a:pPr algn="ctr">
-                        <a:defRPr sz="1400" b="1">
-                          <a:solidFill>
-                            <a:srgbClr val="0F172A"/>
-                          </a:solidFill>
-                          <a:latin typeface="Calibri"/>
-                        </a:defRPr>
-                      </a:pPr>
-                      <a:r>
-                        <a:t>2026-07-06</a:t>
-                      </a:r>
-                    </a:p>
-                  </a:txBody>
-                  <a:tcPr anchor="ctr">
-                    <a:solidFill>
-                      <a:srgbClr val="F8FAFC"/>
-                    </a:solidFill>
-                  </a:tcPr>
-                </a:tc>
-                <a:tc>
-                  <a:txBody>
-                    <a:bodyPr/>
-                    <a:lstStyle/>
-                    <a:p>
-                      <a:pPr algn="ctr">
-                        <a:defRPr sz="2200" b="1">
-                          <a:solidFill>
-                            <a:srgbClr val="B91C1C"/>
-                          </a:solidFill>
-                          <a:latin typeface="Calibri"/>
-                        </a:defRPr>
-                      </a:pPr>
-                      <a:r>
-                        <a:t>63 d</a:t>
-                      </a:r>
-                    </a:p>
-                    <a:p>
-                      <a:pPr algn="ctr">
-                        <a:defRPr sz="1400" b="1">
-                          <a:solidFill>
-                            <a:srgbClr val="B91C1C"/>
-                          </a:solidFill>
-                          <a:latin typeface="Calibri"/>
-                        </a:defRPr>
-                      </a:pPr>
-                      <a:r>
-                        <a:t>[OVERDUE]</a:t>
-                      </a:r>
-                    </a:p>
-                  </a:txBody>
-                  <a:tcPr anchor="ctr">
-                    <a:solidFill>
-                      <a:srgbClr val="F8FAFC"/>
-                    </a:solidFill>
-                  </a:tcPr>
-                </a:tc>
-                <a:tc>
-                  <a:txBody>
-                    <a:bodyPr/>
-                    <a:lstStyle/>
-                    <a:p>
-                      <a:pPr>
-                        <a:defRPr sz="1400">
-                          <a:solidFill>
-                            <a:srgbClr val="0F172A"/>
-                          </a:solidFill>
-                          <a:latin typeface="Calibri"/>
-                        </a:defRPr>
-                      </a:pPr>
-                      <a:r>
-                        <a:rPr lang="en-US" sz="2400" b="1" dirty="0">
-                          <a:solidFill>
-                            <a:srgbClr val="00B050"/>
-                          </a:solidFill>
+                        <a:rPr lang="en-US" sz="1400" kern="1200" dirty="0">
+                          <a:solidFill>
+                            <a:srgbClr val="0F172A"/>
+                          </a:solidFill>
+                          <a:latin typeface="Calibri"/>
+                          <a:ea typeface="+mn-ea"/>
+                          <a:cs typeface="+mn-cs"/>
                         </a:rPr>
-                        <a:t>Closed</a:t>
-                      </a:r>
-                      <a:endParaRPr b="1" dirty="0">
+                        <a:t>Typical drawings submitted currently under review on Aconex</a:t>
+                      </a:r>
+                      <a:endParaRPr sz="1400" kern="1200" dirty="0">
                         <a:solidFill>
-                          <a:srgbClr val="00B050"/>
+                          <a:srgbClr val="0F172A"/>
                         </a:solidFill>
+                        <a:latin typeface="Calibri"/>
+                        <a:ea typeface="+mn-ea"/>
+                        <a:cs typeface="+mn-cs"/>
                       </a:endParaRPr>
                     </a:p>
                   </a:txBody>
@@ -4778,7 +4850,7 @@
                   </a:ext>
                 </a:extLst>
               </a:tr>
-              <a:tr h="1947584">
+              <a:tr h="1874519">
                 <a:tc>
                   <a:txBody>
                     <a:bodyPr/>
@@ -4817,11 +4889,15 @@
                         </a:defRPr>
                       </a:pPr>
                       <a:r>
+                        <a:rPr dirty="0"/>
                         <a:t>BV-BSW-105-0000-</a:t>
                       </a:r>
-                      <a:br/>
-                      <a:r>
-                        <a:t>SOA-NCR-QL-000028</a:t>
+                      <a:br>
+                        <a:rPr dirty="0"/>
+                      </a:br>
+                      <a:r>
+                        <a:rPr dirty="0"/>
+                        <a:t>SOA-NCR-QL-000029</a:t>
                       </a:r>
                     </a:p>
                     <a:p>
@@ -4834,7 +4910,8 @@
                         </a:defRPr>
                       </a:pPr>
                       <a:r>
-                        <a:t>Civil (Zone 5 L0 to L1)</a:t>
+                        <a:rPr dirty="0"/>
+                        <a:t>Arch / MEP (Basement B2)</a:t>
                       </a:r>
                     </a:p>
                   </a:txBody>
@@ -4858,7 +4935,8 @@
                         </a:defRPr>
                       </a:pPr>
                       <a:r>
-                        <a:t>ACROW clearance issued without verification, causing fresh concrete slurry leak into B2 elevator shaft.</a:t>
+                        <a:rPr dirty="0"/>
+                        <a:t>MEP installations (HDPE hanging drainage pipes) commenced prior to architectural clearance and painting completion.</a:t>
                       </a:r>
                     </a:p>
                   </a:txBody>
@@ -4882,7 +4960,8 @@
                         </a:defRPr>
                       </a:pPr>
                       <a:r>
-                        <a:t>Enforce strict ACROW pre-pour physical site checks; seal formwork joints; clean elevator shaft; submit formal CAPA.</a:t>
+                        <a:rPr dirty="0"/>
+                        <a:t>Suspend MEP works; remove HDPE pipes for painting completion; introduce mandatory Area Acceptance Record (AAR).</a:t>
                       </a:r>
                     </a:p>
                   </a:txBody>
@@ -4906,7 +4985,7 @@
                         </a:defRPr>
                       </a:pPr>
                       <a:r>
-                        <a:t>2026-07-12</a:t>
+                        <a:t>2026-07-13</a:t>
                       </a:r>
                     </a:p>
                   </a:txBody>
@@ -4924,26 +5003,32 @@
                       <a:pPr algn="ctr">
                         <a:defRPr sz="2200" b="1">
                           <a:solidFill>
-                            <a:srgbClr val="0F172A"/>
-                          </a:solidFill>
-                          <a:latin typeface="Calibri"/>
-                        </a:defRPr>
-                      </a:pPr>
-                      <a:r>
-                        <a:t>57 d</a:t>
-                      </a:r>
-                    </a:p>
-                    <a:p>
-                      <a:pPr algn="ctr">
-                        <a:defRPr sz="1200">
-                          <a:solidFill>
-                            <a:srgbClr val="64748B"/>
-                          </a:solidFill>
-                          <a:latin typeface="Calibri"/>
-                        </a:defRPr>
-                      </a:pPr>
-                      <a:r>
-                        <a:t>[&lt; 2 Months]</a:t>
+                            <a:srgbClr val="B91C1C"/>
+                          </a:solidFill>
+                          <a:latin typeface="Calibri"/>
+                        </a:defRPr>
+                      </a:pPr>
+                      <a:r>
+                        <a:rPr lang="en-US" dirty="0"/>
+                        <a:t>76</a:t>
+                      </a:r>
+                      <a:r>
+                        <a:rPr dirty="0"/>
+                        <a:t> d</a:t>
+                      </a:r>
+                    </a:p>
+                    <a:p>
+                      <a:pPr algn="ctr">
+                        <a:defRPr sz="1400" b="1">
+                          <a:solidFill>
+                            <a:srgbClr val="B91C1C"/>
+                          </a:solidFill>
+                          <a:latin typeface="Calibri"/>
+                        </a:defRPr>
+                      </a:pPr>
+                      <a:r>
+                        <a:rPr dirty="0"/>
+                        <a:t>[OVERDUE]</a:t>
                       </a:r>
                     </a:p>
                   </a:txBody>
@@ -4968,15 +5053,7 @@
                       </a:pPr>
                       <a:r>
                         <a:rPr lang="en-US" dirty="0"/>
-                        <a:t>Formwork is typical for all the areas, any special areas formwork </a:t>
-                      </a:r>
-                      <a:r>
-                        <a:rPr lang="en-US" dirty="0" err="1"/>
-                        <a:t>drwg</a:t>
-                      </a:r>
-                      <a:r>
-                        <a:rPr lang="en-US" dirty="0"/>
-                        <a:t> will be submitted</a:t>
+                        <a:t>MEP proposal has been submitted to CSC, which outlines utilities can be removed in some areas and remain in other area for sofit finishing.</a:t>
                       </a:r>
                       <a:endParaRPr dirty="0"/>
                     </a:p>
@@ -5075,7 +5152,7 @@
           <p:nvPr>
             <p:extLst>
               <p:ext uri="{D42A27DB-BD31-4B8C-83A1-F6EECF244321}">
-                <p14:modId xmlns:p14="http://schemas.microsoft.com/office/powerpoint/2010/main" val="3684254833"/>
+                <p14:modId xmlns:p14="http://schemas.microsoft.com/office/powerpoint/2010/main" val="3086914579"/>
               </p:ext>
             </p:extLst>
           </p:nvPr>
@@ -5355,11 +5432,15 @@
                         </a:defRPr>
                       </a:pPr>
                       <a:r>
+                        <a:rPr dirty="0"/>
                         <a:t>BV-BSW-105-0000-</a:t>
                       </a:r>
-                      <a:br/>
-                      <a:r>
-                        <a:t>SOA-NCR-QL-000029</a:t>
+                      <a:br>
+                        <a:rPr dirty="0"/>
+                      </a:br>
+                      <a:r>
+                        <a:rPr dirty="0"/>
+                        <a:t>SOA-NCR-QL-000031</a:t>
                       </a:r>
                     </a:p>
                     <a:p>
@@ -5372,7 +5453,8 @@
                         </a:defRPr>
                       </a:pPr>
                       <a:r>
-                        <a:t>Arch / MEP (Basement B2)</a:t>
+                        <a:rPr dirty="0"/>
+                        <a:t>Civil (Zone 4 L0)</a:t>
                       </a:r>
                     </a:p>
                   </a:txBody>
@@ -5396,7 +5478,8 @@
                         </a:defRPr>
                       </a:pPr>
                       <a:r>
-                        <a:t>MEP installations (HDPE hanging drainage pipes) commenced prior to architectural clearance and painting completion.</a:t>
+                        <a:rPr dirty="0"/>
+                        <a:t>Unauthorized cutting and drilling into completed RC structural wall for placing boom support without CSC approval.</a:t>
                       </a:r>
                     </a:p>
                   </a:txBody>
@@ -5420,7 +5503,8 @@
                         </a:defRPr>
                       </a:pPr>
                       <a:r>
-                        <a:t>Suspend MEP works; remove HDPE pipes for painting completion; introduce mandatory Area Acceptance Record (AAR).</a:t>
+                        <a:rPr dirty="0"/>
+                        <a:t>Isolate wall; submit boom reaction calculations and opening closure MS; repair damaged rebar/concrete; hold TBT.</a:t>
                       </a:r>
                     </a:p>
                   </a:txBody>
@@ -5444,7 +5528,7 @@
                         </a:defRPr>
                       </a:pPr>
                       <a:r>
-                        <a:t>2026-07-13</a:t>
+                        <a:t>2026-07-19</a:t>
                       </a:r>
                     </a:p>
                   </a:txBody>
@@ -5462,26 +5546,28 @@
                       <a:pPr algn="ctr">
                         <a:defRPr sz="2200" b="1">
                           <a:solidFill>
-                            <a:srgbClr val="0F172A"/>
-                          </a:solidFill>
-                          <a:latin typeface="Calibri"/>
-                        </a:defRPr>
-                      </a:pPr>
-                      <a:r>
-                        <a:t>56 d</a:t>
-                      </a:r>
-                    </a:p>
-                    <a:p>
-                      <a:pPr algn="ctr">
-                        <a:defRPr sz="1200">
-                          <a:solidFill>
-                            <a:srgbClr val="64748B"/>
-                          </a:solidFill>
-                          <a:latin typeface="Calibri"/>
-                        </a:defRPr>
-                      </a:pPr>
-                      <a:r>
-                        <a:t>[&lt; 2 Months]</a:t>
+                            <a:srgbClr val="B91C1C"/>
+                          </a:solidFill>
+                          <a:latin typeface="Calibri"/>
+                        </a:defRPr>
+                      </a:pPr>
+                      <a:r>
+                        <a:rPr lang="en-US" dirty="0"/>
+                        <a:t>70 d</a:t>
+                      </a:r>
+                    </a:p>
+                    <a:p>
+                      <a:pPr algn="ctr">
+                        <a:defRPr sz="1400" b="1">
+                          <a:solidFill>
+                            <a:srgbClr val="B91C1C"/>
+                          </a:solidFill>
+                          <a:latin typeface="Calibri"/>
+                        </a:defRPr>
+                      </a:pPr>
+                      <a:r>
+                        <a:rPr lang="en-US" dirty="0"/>
+                        <a:t>[OVERDUE]</a:t>
                       </a:r>
                     </a:p>
                   </a:txBody>
@@ -5505,12 +5591,24 @@
                         </a:defRPr>
                       </a:pPr>
                       <a:r>
-                        <a:rPr dirty="0"/>
-                        <a:t>CAPA Approved — </a:t>
-                      </a:r>
-                      <a:r>
                         <a:rPr lang="en-US" dirty="0"/>
-                        <a:t>AAR is complete, WIR is under review</a:t>
+                        <a:t>CAPA Approved (Code B) — Str calc and </a:t>
+                      </a:r>
+                      <a:r>
+                        <a:rPr lang="en-US" dirty="0" err="1"/>
+                        <a:t>drwg</a:t>
+                      </a:r>
+                      <a:r>
+                        <a:rPr lang="en-US" dirty="0"/>
+                        <a:t> will be submitted by 1</a:t>
+                      </a:r>
+                      <a:r>
+                        <a:rPr lang="en-US" baseline="30000" dirty="0"/>
+                        <a:t>st</a:t>
+                      </a:r>
+                      <a:r>
+                        <a:rPr lang="en-US" dirty="0"/>
+                        <a:t> Oct 2026.</a:t>
                       </a:r>
                       <a:endParaRPr dirty="0"/>
                     </a:p>
@@ -5570,7 +5668,7 @@
                       </a:r>
                       <a:br/>
                       <a:r>
-                        <a:t>SOA-NCR-QL-000031</a:t>
+                        <a:t>SOA-NCR-QL-000032</a:t>
                       </a:r>
                     </a:p>
                     <a:p>
@@ -5583,7 +5681,7 @@
                         </a:defRPr>
                       </a:pPr>
                       <a:r>
-                        <a:t>Civil (Zone 4 L0)</a:t>
+                        <a:t>Architectural (Zones 2, 3, 5, 6 – B2)</a:t>
                       </a:r>
                     </a:p>
                   </a:txBody>
@@ -5607,7 +5705,7 @@
                         </a:defRPr>
                       </a:pPr>
                       <a:r>
-                        <a:t>Unauthorized cutting and drilling into completed RC structural wall for placing boom support without CSC approval.</a:t>
+                        <a:t>Repeated unauthorized bond beam casting and blockwork without approved builder drawings or MEP clearance.</a:t>
                       </a:r>
                     </a:p>
                   </a:txBody>
@@ -5631,7 +5729,7 @@
                         </a:defRPr>
                       </a:pPr>
                       <a:r>
-                        <a:t>Isolate wall; submit boom reaction calculations and opening closure MS; repair damaged rebar/concrete; hold TBT.</a:t>
+                        <a:t>Submitted updated elevation drawings (WF-220202); confirmed structural calculations (WF-200995); conduct TBT.</a:t>
                       </a:r>
                     </a:p>
                   </a:txBody>
@@ -5655,7 +5753,7 @@
                         </a:defRPr>
                       </a:pPr>
                       <a:r>
-                        <a:t>2026-07-19</a:t>
+                        <a:t>2026-07-30</a:t>
                       </a:r>
                     </a:p>
                   </a:txBody>
@@ -5679,12 +5777,12 @@
                         </a:defRPr>
                       </a:pPr>
                       <a:r>
-                        <a:t>50 d</a:t>
-                      </a:r>
-                    </a:p>
-                    <a:p>
-                      <a:pPr algn="ctr">
-                        <a:defRPr sz="1200">
+                        <a:t>48 d</a:t>
+                      </a:r>
+                    </a:p>
+                    <a:p>
+                      <a:pPr algn="ctr">
+                        <a:defRPr sz="1200" b="1">
                           <a:solidFill>
                             <a:srgbClr val="64748B"/>
                           </a:solidFill>
@@ -5707,21 +5805,7 @@
                     <a:bodyPr/>
                     <a:lstStyle/>
                     <a:p>
-                      <a:pPr marL="0" marR="0" lvl="0" indent="0" algn="l" defTabSz="457200" rtl="0" eaLnBrk="1" fontAlgn="auto" latinLnBrk="0" hangingPunct="1">
-                        <a:lnSpc>
-                          <a:spcPct val="100000"/>
-                        </a:lnSpc>
-                        <a:spcBef>
-                          <a:spcPts val="0"/>
-                        </a:spcBef>
-                        <a:spcAft>
-                          <a:spcPts val="0"/>
-                        </a:spcAft>
-                        <a:buClrTx/>
-                        <a:buSzTx/>
-                        <a:buFontTx/>
-                        <a:buNone/>
-                        <a:tabLst/>
+                      <a:pPr>
                         <a:defRPr sz="1400">
                           <a:solidFill>
                             <a:srgbClr val="0F172A"/>
@@ -5730,57 +5814,8 @@
                         </a:defRPr>
                       </a:pPr>
                       <a:r>
-                        <a:rPr lang="en-US" dirty="0"/>
-                        <a:t>CAPA Approved (Code B</a:t>
-                      </a:r>
-                      <a:r>
-                        <a:rPr dirty="0"/>
-                        <a:t>) —</a:t>
-                      </a:r>
-                      <a:r>
-                        <a:rPr lang="en-US" dirty="0"/>
-                        <a:t> </a:t>
-                      </a:r>
-                      <a:r>
-                        <a:rPr lang="en-US" dirty="0">
-                          <a:solidFill>
-                            <a:srgbClr val="FFC000"/>
-                          </a:solidFill>
-                        </a:rPr>
-                        <a:t>Str calc and </a:t>
-                      </a:r>
-                      <a:r>
-                        <a:rPr lang="en-US" dirty="0" err="1">
-                          <a:solidFill>
-                            <a:srgbClr val="FFC000"/>
-                          </a:solidFill>
-                        </a:rPr>
-                        <a:t>drwg</a:t>
-                      </a:r>
-                      <a:r>
-                        <a:rPr lang="en-US" dirty="0">
-                          <a:solidFill>
-                            <a:srgbClr val="FFC000"/>
-                          </a:solidFill>
-                        </a:rPr>
-                        <a:t> to be submitted for approval</a:t>
-                      </a:r>
-                      <a:endParaRPr lang="en-US" dirty="0"/>
-                    </a:p>
-                    <a:p>
-                      <a:pPr>
-                        <a:defRPr sz="1400">
-                          <a:solidFill>
-                            <a:srgbClr val="0F172A"/>
-                          </a:solidFill>
-                          <a:latin typeface="Calibri"/>
-                        </a:defRPr>
-                      </a:pPr>
-                      <a:endParaRPr dirty="0">
-                        <a:solidFill>
-                          <a:srgbClr val="FFC000"/>
-                        </a:solidFill>
-                      </a:endParaRPr>
+                        <a:t>Response same as NCR-26 — Drawings Code C (room ID/Name); elevation drawings under resubmission.</a:t>
+                      </a:r>
                     </a:p>
                   </a:txBody>
                   <a:tcPr anchor="ctr">
@@ -5838,7 +5873,7 @@
                       </a:r>
                       <a:br/>
                       <a:r>
-                        <a:t>SOA-NCR-QL-000032</a:t>
+                        <a:t>SOA-NCR-QL-000033</a:t>
                       </a:r>
                     </a:p>
                     <a:p>
@@ -5851,7 +5886,7 @@
                         </a:defRPr>
                       </a:pPr>
                       <a:r>
-                        <a:t>Architectural (Zones 2, 3, 5, 6 – B2)</a:t>
+                        <a:t>Architectural (Zones 9, 10, 11 – B2)</a:t>
                       </a:r>
                     </a:p>
                   </a:txBody>
@@ -5875,7 +5910,7 @@
                         </a:defRPr>
                       </a:pPr>
                       <a:r>
-                        <a:t>Repeated unauthorized bond beam casting and blockwork without approved builder drawings or MEP clearance.</a:t>
+                        <a:t>Repeated failure to achieve specified SF3 fair-faced concrete finish quality: formwork misalignment, honeycombing.</a:t>
                       </a:r>
                     </a:p>
                   </a:txBody>
@@ -5899,7 +5934,7 @@
                         </a:defRPr>
                       </a:pPr>
                       <a:r>
-                        <a:t>Submitted updated elevation drawings (WF-220202); confirmed structural calculations (WF-200995); conduct TBT.</a:t>
+                        <a:t>Finalize comprehensive SF3 repair method statement; execute repair mock-ups for consultant inspection.</a:t>
                       </a:r>
                     </a:p>
                   </a:txBody>
@@ -5923,7 +5958,7 @@
                         </a:defRPr>
                       </a:pPr>
                       <a:r>
-                        <a:t>2026-07-30</a:t>
+                        <a:t>2026-08-05</a:t>
                       </a:r>
                     </a:p>
                   </a:txBody>
@@ -5947,12 +5982,12 @@
                         </a:defRPr>
                       </a:pPr>
                       <a:r>
-                        <a:t>39 d</a:t>
-                      </a:r>
-                    </a:p>
-                    <a:p>
-                      <a:pPr algn="ctr">
-                        <a:defRPr sz="1200">
+                        <a:t>42 d</a:t>
+                      </a:r>
+                    </a:p>
+                    <a:p>
+                      <a:pPr algn="ctr">
+                        <a:defRPr sz="1200" b="1">
                           <a:solidFill>
                             <a:srgbClr val="64748B"/>
                           </a:solidFill>
@@ -5985,7 +6020,7 @@
                       </a:pPr>
                       <a:r>
                         <a:rPr dirty="0"/>
-                        <a:t>Response same as NCR-26 — Drawings Code C (room ID/Name); elevation drawings under resubmission.</a:t>
+                        <a:t>MST for SF2 &amp; SF3 has been submitted</a:t>
                       </a:r>
                     </a:p>
                   </a:txBody>
@@ -6083,7 +6118,7 @@
           <p:nvPr>
             <p:extLst>
               <p:ext uri="{D42A27DB-BD31-4B8C-83A1-F6EECF244321}">
-                <p14:modId xmlns:p14="http://schemas.microsoft.com/office/powerpoint/2010/main" val="1005351883"/>
+                <p14:modId xmlns:p14="http://schemas.microsoft.com/office/powerpoint/2010/main" val="965239415"/>
               </p:ext>
             </p:extLst>
           </p:nvPr>
@@ -6367,7 +6402,7 @@
                       </a:r>
                       <a:br/>
                       <a:r>
-                        <a:t>SOA-NCR-QL-000033</a:t>
+                        <a:t>SOA-NCR-QL-000034</a:t>
                       </a:r>
                     </a:p>
                     <a:p>
@@ -6380,7 +6415,7 @@
                         </a:defRPr>
                       </a:pPr>
                       <a:r>
-                        <a:t>Architectural (Zones 9, 10, 11 – B2)</a:t>
+                        <a:t>Civil (Zone 1)</a:t>
                       </a:r>
                     </a:p>
                   </a:txBody>
@@ -6404,7 +6439,7 @@
                         </a:defRPr>
                       </a:pPr>
                       <a:r>
-                        <a:t>Repeated failure to achieve specified SF3 fair-faced concrete finish quality: formwork misalignment, honeycombing.</a:t>
+                        <a:t>Unauthorized concrete casting resulting in missing additional reinforcement around embedded steel plates in Zone 1.</a:t>
                       </a:r>
                     </a:p>
                   </a:txBody>
@@ -6428,7 +6463,7 @@
                         </a:defRPr>
                       </a:pPr>
                       <a:r>
-                        <a:t>Finalize comprehensive SF3 repair method statement; execute repair mock-ups for consultant inspection.</a:t>
+                        <a:t>Submit detailed CAPA with structural justification/NDT; work on hold at affected location until approved.</a:t>
                       </a:r>
                     </a:p>
                   </a:txBody>
@@ -6452,7 +6487,7 @@
                         </a:defRPr>
                       </a:pPr>
                       <a:r>
-                        <a:t>2026-08-05</a:t>
+                        <a:t>2026-08-12</a:t>
                       </a:r>
                     </a:p>
                   </a:txBody>
@@ -6476,12 +6511,12 @@
                         </a:defRPr>
                       </a:pPr>
                       <a:r>
-                        <a:t>33 d</a:t>
-                      </a:r>
-                    </a:p>
-                    <a:p>
-                      <a:pPr algn="ctr">
-                        <a:defRPr sz="1200">
+                        <a:t>35 d</a:t>
+                      </a:r>
+                    </a:p>
+                    <a:p>
+                      <a:pPr algn="ctr">
+                        <a:defRPr sz="1200" b="1">
                           <a:solidFill>
                             <a:srgbClr val="64748B"/>
                           </a:solidFill>
@@ -6513,8 +6548,22 @@
                         </a:defRPr>
                       </a:pPr>
                       <a:r>
-                        <a:t>MST for SF2 &amp; SF3 has been submitted</a:t>
-                      </a:r>
+                        <a:rPr dirty="0"/>
+                        <a:t>CAPA Approved </a:t>
+                      </a:r>
+                      <a:r>
+                        <a:rPr lang="en-US" dirty="0"/>
+                        <a:t>submitted on 22</a:t>
+                      </a:r>
+                      <a:r>
+                        <a:rPr lang="en-US" baseline="30000" dirty="0"/>
+                        <a:t>nd</a:t>
+                      </a:r>
+                      <a:r>
+                        <a:rPr lang="en-US" dirty="0"/>
+                        <a:t>  Sep.</a:t>
+                      </a:r>
+                      <a:endParaRPr dirty="0"/>
                     </a:p>
                   </a:txBody>
                   <a:tcPr anchor="ctr">
@@ -6568,15 +6617,11 @@
                         </a:defRPr>
                       </a:pPr>
                       <a:r>
-                        <a:rPr dirty="0"/>
                         <a:t>BV-BSW-105-0000-</a:t>
                       </a:r>
-                      <a:br>
-                        <a:rPr dirty="0"/>
-                      </a:br>
-                      <a:r>
-                        <a:rPr dirty="0"/>
-                        <a:t>SOA-NCR-QL-000034</a:t>
+                      <a:br/>
+                      <a:r>
+                        <a:t>SOA-NCR-QL-000035</a:t>
                       </a:r>
                     </a:p>
                     <a:p>
@@ -6589,8 +6634,7 @@
                         </a:defRPr>
                       </a:pPr>
                       <a:r>
-                        <a:rPr dirty="0"/>
-                        <a:t>Civil (Zone 1)</a:t>
+                        <a:t>Architectural (Zone 10-B1)</a:t>
                       </a:r>
                     </a:p>
                   </a:txBody>
@@ -6614,7 +6658,7 @@
                         </a:defRPr>
                       </a:pPr>
                       <a:r>
-                        <a:t>Unauthorized concrete casting resulting in missing additional reinforcement around embedded steel plates in Zone 1.</a:t>
+                        <a:t>Repeated unauthorized SF3 repair works on fair-faced concrete walls using unapproved cement mortar patches.</a:t>
                       </a:r>
                     </a:p>
                   </a:txBody>
@@ -6638,7 +6682,7 @@
                         </a:defRPr>
                       </a:pPr>
                       <a:r>
-                        <a:t>Submit detailed CAPA with structural justification/NDT; work on hold at affected location until approved.</a:t>
+                        <a:t>Remove unapproved cement patches; execute repairs strictly using approved MAR materials and inspected WIRs.</a:t>
                       </a:r>
                     </a:p>
                   </a:txBody>
@@ -6662,7 +6706,7 @@
                         </a:defRPr>
                       </a:pPr>
                       <a:r>
-                        <a:t>2026-08-12</a:t>
+                        <a:t>2026-08-13</a:t>
                       </a:r>
                     </a:p>
                   </a:txBody>
@@ -6686,12 +6730,12 @@
                         </a:defRPr>
                       </a:pPr>
                       <a:r>
-                        <a:t>26 d</a:t>
-                      </a:r>
-                    </a:p>
-                    <a:p>
-                      <a:pPr algn="ctr">
-                        <a:defRPr sz="1200">
+                        <a:t>34 d</a:t>
+                      </a:r>
+                    </a:p>
+                    <a:p>
+                      <a:pPr algn="ctr">
+                        <a:defRPr sz="1200" b="1">
                           <a:solidFill>
                             <a:srgbClr val="64748B"/>
                           </a:solidFill>
@@ -6714,21 +6758,7 @@
                     <a:bodyPr/>
                     <a:lstStyle/>
                     <a:p>
-                      <a:pPr marL="0" marR="0" lvl="0" indent="0" algn="l" defTabSz="457200" rtl="0" eaLnBrk="1" fontAlgn="auto" latinLnBrk="0" hangingPunct="1">
-                        <a:lnSpc>
-                          <a:spcPct val="100000"/>
-                        </a:lnSpc>
-                        <a:spcBef>
-                          <a:spcPts val="0"/>
-                        </a:spcBef>
-                        <a:spcAft>
-                          <a:spcPts val="0"/>
-                        </a:spcAft>
-                        <a:buClrTx/>
-                        <a:buSzTx/>
-                        <a:buFontTx/>
-                        <a:buNone/>
-                        <a:tabLst/>
+                      <a:pPr>
                         <a:defRPr sz="1400">
                           <a:solidFill>
                             <a:srgbClr val="0F172A"/>
@@ -6737,34 +6767,8 @@
                         </a:defRPr>
                       </a:pPr>
                       <a:r>
-                        <a:rPr lang="en-US" dirty="0"/>
-                        <a:t>CAPA Approved (Code B) — </a:t>
-                      </a:r>
-                      <a:r>
-                        <a:rPr lang="en-US" dirty="0">
-                          <a:solidFill>
-                            <a:srgbClr val="FFC000"/>
-                          </a:solidFill>
-                        </a:rPr>
-                        <a:t>Str calc and </a:t>
-                      </a:r>
-                      <a:r>
-                        <a:rPr lang="en-US" dirty="0" err="1">
-                          <a:solidFill>
-                            <a:srgbClr val="FFC000"/>
-                          </a:solidFill>
-                        </a:rPr>
-                        <a:t>drwg</a:t>
-                      </a:r>
-                      <a:r>
-                        <a:rPr lang="en-US" dirty="0">
-                          <a:solidFill>
-                            <a:srgbClr val="FFC000"/>
-                          </a:solidFill>
-                        </a:rPr>
-                        <a:t> to be submitted for approval</a:t>
-                      </a:r>
-                      <a:endParaRPr lang="en-US" dirty="0"/>
+                        <a:t>MST for SF2 &amp; SF3 has been submitted; unauthorized patches mechanically removed.</a:t>
+                      </a:r>
                     </a:p>
                   </a:txBody>
                   <a:tcPr anchor="ctr">
@@ -6822,7 +6826,7 @@
                       </a:r>
                       <a:br/>
                       <a:r>
-                        <a:t>SOA-NCR-QL-000035</a:t>
+                        <a:t>SOA-NCR-QL-000037</a:t>
                       </a:r>
                     </a:p>
                     <a:p>
@@ -6835,7 +6839,7 @@
                         </a:defRPr>
                       </a:pPr>
                       <a:r>
-                        <a:t>Architectural (Zone 10-B1)</a:t>
+                        <a:t>Civil / MEP (B2 Water Tank Wall)</a:t>
                       </a:r>
                     </a:p>
                   </a:txBody>
@@ -6859,7 +6863,7 @@
                         </a:defRPr>
                       </a:pPr>
                       <a:r>
-                        <a:t>Repeated unauthorized SF3 repair works on fair-faced concrete walls using unapproved cement mortar patches.</a:t>
+                        <a:t>Unauthorized demolition of 300 mm cast wall to add 7 missed MEP flanges at B2 Water Tank, damaging water stopper.</a:t>
                       </a:r>
                     </a:p>
                   </a:txBody>
@@ -6883,7 +6887,7 @@
                         </a:defRPr>
                       </a:pPr>
                       <a:r>
-                        <a:t>Remove unapproved cement patches; execute repairs strictly using approved MAR materials and inspected WIRs.</a:t>
+                        <a:t>Immediately stop demolition; submit Root Cause Analysis, structural repair MS, and water stopper reinstatement plan.</a:t>
                       </a:r>
                     </a:p>
                   </a:txBody>
@@ -6907,7 +6911,7 @@
                         </a:defRPr>
                       </a:pPr>
                       <a:r>
-                        <a:t>2026-08-13</a:t>
+                        <a:t>2026-08-17</a:t>
                       </a:r>
                     </a:p>
                   </a:txBody>
@@ -6931,12 +6935,12 @@
                         </a:defRPr>
                       </a:pPr>
                       <a:r>
-                        <a:t>25 d</a:t>
-                      </a:r>
-                    </a:p>
-                    <a:p>
-                      <a:pPr algn="ctr">
-                        <a:defRPr sz="1200">
+                        <a:t>30 d</a:t>
+                      </a:r>
+                    </a:p>
+                    <a:p>
+                      <a:pPr algn="ctr">
+                        <a:defRPr sz="1200" b="1">
                           <a:solidFill>
                             <a:srgbClr val="64748B"/>
                           </a:solidFill>
@@ -6968,9 +6972,18 @@
                         </a:defRPr>
                       </a:pPr>
                       <a:r>
-                        <a:rPr dirty="0"/>
-                        <a:t>MST for SF2 &amp; SF3 has been submitted; unauthorized patches mechanically removed.</a:t>
-                      </a:r>
+                        <a:rPr lang="en-US" sz="1800" b="1" dirty="0">
+                          <a:solidFill>
+                            <a:srgbClr val="00B050"/>
+                          </a:solidFill>
+                        </a:rPr>
+                        <a:t>Closed</a:t>
+                      </a:r>
+                      <a:endParaRPr sz="1800" b="1" dirty="0">
+                        <a:solidFill>
+                          <a:srgbClr val="00B050"/>
+                        </a:solidFill>
+                      </a:endParaRPr>
                     </a:p>
                   </a:txBody>
                   <a:tcPr anchor="ctr">
@@ -7067,7 +7080,7 @@
           <p:nvPr>
             <p:extLst>
               <p:ext uri="{D42A27DB-BD31-4B8C-83A1-F6EECF244321}">
-                <p14:modId xmlns:p14="http://schemas.microsoft.com/office/powerpoint/2010/main" val="2783023913"/>
+                <p14:modId xmlns:p14="http://schemas.microsoft.com/office/powerpoint/2010/main" val="428401513"/>
               </p:ext>
             </p:extLst>
           </p:nvPr>
@@ -7351,7 +7364,7 @@
                       </a:r>
                       <a:br/>
                       <a:r>
-                        <a:t>SOA-NCR-QL-000036</a:t>
+                        <a:t>SOA-NCR-QL-000038</a:t>
                       </a:r>
                     </a:p>
                     <a:p>
@@ -7364,7 +7377,7 @@
                         </a:defRPr>
                       </a:pPr>
                       <a:r>
-                        <a:t>Architectural (Material Storage)</a:t>
+                        <a:t>Civil (Zone 2 – Wall P2-01)</a:t>
                       </a:r>
                     </a:p>
                   </a:txBody>
@@ -7388,7 +7401,7 @@
                         </a:defRPr>
                       </a:pPr>
                       <a:r>
-                        <a:t>Improper storage of Dry Mix Mortar bags directly on ground in open area exposed to rain, moisture, and contamination.</a:t>
+                        <a:t>Unauthorized cutting and welding of structural reinforcement bars to fit embedded plates at Zone 2.</a:t>
                       </a:r>
                     </a:p>
                   </a:txBody>
@@ -7412,7 +7425,7 @@
                         </a:defRPr>
                       </a:pPr>
                       <a:r>
-                        <a:t>Improve storage controls to prevent moisture; halt unapproved dry mix and switch to approved Premix bags (WP-500C12.4).</a:t>
+                        <a:t>Submit structural justification, rebar repair details, and CAPA for Consultant review; hold further works.</a:t>
                       </a:r>
                     </a:p>
                   </a:txBody>
@@ -7436,7 +7449,7 @@
                         </a:defRPr>
                       </a:pPr>
                       <a:r>
-                        <a:t>2026-08-13</a:t>
+                        <a:t>2026-08-20</a:t>
                       </a:r>
                     </a:p>
                   </a:txBody>
@@ -7460,12 +7473,12 @@
                         </a:defRPr>
                       </a:pPr>
                       <a:r>
-                        <a:t>25 d</a:t>
-                      </a:r>
-                    </a:p>
-                    <a:p>
-                      <a:pPr algn="ctr">
-                        <a:defRPr sz="1200">
+                        <a:t>27 d</a:t>
+                      </a:r>
+                    </a:p>
+                    <a:p>
+                      <a:pPr algn="ctr">
+                        <a:defRPr sz="1200" b="1">
                           <a:solidFill>
                             <a:srgbClr val="64748B"/>
                           </a:solidFill>
@@ -7497,14 +7510,14 @@
                         </a:defRPr>
                       </a:pPr>
                       <a:r>
-                        <a:rPr lang="en-US" sz="1400" b="1" dirty="0">
+                        <a:rPr lang="en-US" sz="1600" b="1" dirty="0">
                           <a:solidFill>
                             <a:srgbClr val="00B050"/>
                           </a:solidFill>
                         </a:rPr>
-                        <a:t>Closed</a:t>
-                      </a:r>
-                      <a:endParaRPr lang="en-US" b="1" dirty="0">
+                        <a:t>WIR is submitted for close-out</a:t>
+                      </a:r>
+                      <a:endParaRPr sz="1600" b="1" dirty="0">
                         <a:solidFill>
                           <a:srgbClr val="00B050"/>
                         </a:solidFill>
@@ -7562,15 +7575,11 @@
                         </a:defRPr>
                       </a:pPr>
                       <a:r>
-                        <a:rPr dirty="0"/>
                         <a:t>BV-BSW-105-0000-</a:t>
                       </a:r>
-                      <a:br>
-                        <a:rPr dirty="0"/>
-                      </a:br>
-                      <a:r>
-                        <a:rPr dirty="0"/>
-                        <a:t>SOA-NCR-QL-000037</a:t>
+                      <a:br/>
+                      <a:r>
+                        <a:t>SOA-NCR-QL-000039</a:t>
                       </a:r>
                     </a:p>
                     <a:p>
@@ -7583,8 +7592,7 @@
                         </a:defRPr>
                       </a:pPr>
                       <a:r>
-                        <a:rPr dirty="0"/>
-                        <a:t>Civil / MEP (B2 Water Tank Wall)</a:t>
+                        <a:t>Façade (Façade Mockup)</a:t>
                       </a:r>
                     </a:p>
                   </a:txBody>
@@ -7608,7 +7616,7 @@
                         </a:defRPr>
                       </a:pPr>
                       <a:r>
-                        <a:t>Unauthorized demolition of 300 mm cast wall to add 7 missed MEP flanges at B2 Water Tank, damaging water stopper.</a:t>
+                        <a:t>JANGHO unauthorized welding on Façade Mockup: no approved WPS, uncertified welders, non-compliant with AWS D1.1.</a:t>
                       </a:r>
                     </a:p>
                   </a:txBody>
@@ -7632,7 +7640,7 @@
                         </a:defRPr>
                       </a:pPr>
                       <a:r>
-                        <a:t>Immediately stop demolition; submit Root Cause Analysis, structural repair MS, and water stopper reinstatement plan.</a:t>
+                        <a:t>Suspended welding works; submit WPS, welder qualification records, calibration certificates, and Welding MS &amp; ITP.</a:t>
                       </a:r>
                     </a:p>
                   </a:txBody>
@@ -7656,7 +7664,7 @@
                         </a:defRPr>
                       </a:pPr>
                       <a:r>
-                        <a:t>2026-08-17</a:t>
+                        <a:t>2026-08-20</a:t>
                       </a:r>
                     </a:p>
                   </a:txBody>
@@ -7680,12 +7688,12 @@
                         </a:defRPr>
                       </a:pPr>
                       <a:r>
-                        <a:t>21 d</a:t>
-                      </a:r>
-                    </a:p>
-                    <a:p>
-                      <a:pPr algn="ctr">
-                        <a:defRPr sz="1200">
+                        <a:t>27 d</a:t>
+                      </a:r>
+                    </a:p>
+                    <a:p>
+                      <a:pPr algn="ctr">
+                        <a:defRPr sz="1200" b="1">
                           <a:solidFill>
                             <a:srgbClr val="64748B"/>
                           </a:solidFill>
@@ -7717,20 +7725,7 @@
                         </a:defRPr>
                       </a:pPr>
                       <a:r>
-                        <a:rPr dirty="0"/>
-                        <a:t>CAPA Approved (Code B on 03-Sep) </a:t>
-                      </a:r>
-                      <a:r>
-                        <a:rPr lang="en-US" dirty="0">
-                          <a:solidFill>
-                            <a:srgbClr val="00B050"/>
-                          </a:solidFill>
-                        </a:rPr>
-                        <a:t>WIR submitted for close out</a:t>
-                      </a:r>
-                      <a:r>
-                        <a:rPr dirty="0"/>
-                        <a:t>— Water-stop reinstatement and patch repairs proceeding under supervision.</a:t>
+                        <a:t>NDT inspection completed on 3rd Sep; welder qualification package under final compilation. WPS, MAT, MST(UR)</a:t>
                       </a:r>
                     </a:p>
                   </a:txBody>
@@ -7785,177 +7780,159 @@
                         </a:defRPr>
                       </a:pPr>
                       <a:r>
+                        <a:t>BV-BSW-105-0000-</a:t>
+                      </a:r>
+                      <a:br/>
+                      <a:r>
+                        <a:t>SOA-NCR-QL-000040</a:t>
+                      </a:r>
+                    </a:p>
+                    <a:p>
+                      <a:pPr>
+                        <a:defRPr sz="1400" b="1">
+                          <a:solidFill>
+                            <a:srgbClr val="B45309"/>
+                          </a:solidFill>
+                          <a:latin typeface="Calibri"/>
+                        </a:defRPr>
+                      </a:pPr>
+                      <a:r>
+                        <a:t>Documentation / QA/QC KPI</a:t>
+                      </a:r>
+                    </a:p>
+                  </a:txBody>
+                  <a:tcPr anchor="ctr">
+                    <a:solidFill>
+                      <a:srgbClr val="FFFFFF"/>
+                    </a:solidFill>
+                  </a:tcPr>
+                </a:tc>
+                <a:tc>
+                  <a:txBody>
+                    <a:bodyPr/>
+                    <a:lstStyle/>
+                    <a:p>
+                      <a:pPr>
+                        <a:defRPr sz="1400">
+                          <a:solidFill>
+                            <a:srgbClr val="0F172A"/>
+                          </a:solidFill>
+                          <a:latin typeface="Calibri"/>
+                        </a:defRPr>
+                      </a:pPr>
+                      <a:r>
+                        <a:t>High Code C rate on Material Submittals (84 submittals at Code C; KPI &lt; 70% vs mandatory 90% project requirement).</a:t>
+                      </a:r>
+                    </a:p>
+                  </a:txBody>
+                  <a:tcPr anchor="ctr">
+                    <a:solidFill>
+                      <a:srgbClr val="FFFFFF"/>
+                    </a:solidFill>
+                  </a:tcPr>
+                </a:tc>
+                <a:tc>
+                  <a:txBody>
+                    <a:bodyPr/>
+                    <a:lstStyle/>
+                    <a:p>
+                      <a:pPr>
+                        <a:defRPr sz="1400">
+                          <a:solidFill>
+                            <a:srgbClr val="0F172A"/>
+                          </a:solidFill>
+                          <a:latin typeface="Calibri"/>
+                        </a:defRPr>
+                      </a:pPr>
+                      <a:r>
+                        <a:t>Enforce strict internal technical QA/QC review; withdraw non-applicable submittals; submit recovery plan to reach 90% KPI.</a:t>
+                      </a:r>
+                    </a:p>
+                  </a:txBody>
+                  <a:tcPr anchor="ctr">
+                    <a:solidFill>
+                      <a:srgbClr val="FFFFFF"/>
+                    </a:solidFill>
+                  </a:tcPr>
+                </a:tc>
+                <a:tc>
+                  <a:txBody>
+                    <a:bodyPr/>
+                    <a:lstStyle/>
+                    <a:p>
+                      <a:pPr algn="ctr">
+                        <a:defRPr sz="1400" b="1">
+                          <a:solidFill>
+                            <a:srgbClr val="0F172A"/>
+                          </a:solidFill>
+                          <a:latin typeface="Calibri"/>
+                        </a:defRPr>
+                      </a:pPr>
+                      <a:r>
+                        <a:t>2026-08-25</a:t>
+                      </a:r>
+                    </a:p>
+                  </a:txBody>
+                  <a:tcPr anchor="ctr">
+                    <a:solidFill>
+                      <a:srgbClr val="FFFFFF"/>
+                    </a:solidFill>
+                  </a:tcPr>
+                </a:tc>
+                <a:tc>
+                  <a:txBody>
+                    <a:bodyPr/>
+                    <a:lstStyle/>
+                    <a:p>
+                      <a:pPr algn="ctr">
+                        <a:defRPr sz="2200" b="1">
+                          <a:solidFill>
+                            <a:srgbClr val="0F172A"/>
+                          </a:solidFill>
+                          <a:latin typeface="Calibri"/>
+                        </a:defRPr>
+                      </a:pPr>
+                      <a:r>
+                        <a:t>22 d</a:t>
+                      </a:r>
+                    </a:p>
+                    <a:p>
+                      <a:pPr algn="ctr">
+                        <a:defRPr sz="1200" b="1">
+                          <a:solidFill>
+                            <a:srgbClr val="64748B"/>
+                          </a:solidFill>
+                          <a:latin typeface="Calibri"/>
+                        </a:defRPr>
+                      </a:pPr>
+                      <a:r>
+                        <a:t>[&lt; 2 Months]</a:t>
+                      </a:r>
+                    </a:p>
+                  </a:txBody>
+                  <a:tcPr anchor="ctr">
+                    <a:solidFill>
+                      <a:srgbClr val="FFFFFF"/>
+                    </a:solidFill>
+                  </a:tcPr>
+                </a:tc>
+                <a:tc>
+                  <a:txBody>
+                    <a:bodyPr/>
+                    <a:lstStyle/>
+                    <a:p>
+                      <a:pPr>
+                        <a:defRPr sz="1400">
+                          <a:solidFill>
+                            <a:srgbClr val="0F172A"/>
+                          </a:solidFill>
+                          <a:latin typeface="Calibri"/>
+                        </a:defRPr>
+                      </a:pPr>
+                      <a:r>
                         <a:rPr dirty="0"/>
-                        <a:t>BV-BSW-105-0000-</a:t>
-                      </a:r>
-                      <a:br>
-                        <a:rPr dirty="0"/>
-                      </a:br>
-                      <a:r>
-                        <a:rPr dirty="0"/>
-                        <a:t>SOA-NCR-QL-000038</a:t>
-                      </a:r>
-                    </a:p>
-                    <a:p>
-                      <a:pPr>
-                        <a:defRPr sz="1400" b="1">
-                          <a:solidFill>
-                            <a:srgbClr val="B45309"/>
-                          </a:solidFill>
-                          <a:latin typeface="Calibri"/>
-                        </a:defRPr>
-                      </a:pPr>
-                      <a:r>
-                        <a:rPr dirty="0"/>
-                        <a:t>Civil (Zone 2 – Wall P2-01)</a:t>
-                      </a:r>
-                    </a:p>
-                  </a:txBody>
-                  <a:tcPr anchor="ctr">
-                    <a:solidFill>
-                      <a:srgbClr val="FFFFFF"/>
-                    </a:solidFill>
-                  </a:tcPr>
-                </a:tc>
-                <a:tc>
-                  <a:txBody>
-                    <a:bodyPr/>
-                    <a:lstStyle/>
-                    <a:p>
-                      <a:pPr>
-                        <a:defRPr sz="1400">
-                          <a:solidFill>
-                            <a:srgbClr val="0F172A"/>
-                          </a:solidFill>
-                          <a:latin typeface="Calibri"/>
-                        </a:defRPr>
-                      </a:pPr>
-                      <a:r>
-                        <a:t>Unauthorized cutting and welding of structural reinforcement bars to fit embedded plates at Zone 2.</a:t>
-                      </a:r>
-                    </a:p>
-                  </a:txBody>
-                  <a:tcPr anchor="ctr">
-                    <a:solidFill>
-                      <a:srgbClr val="FFFFFF"/>
-                    </a:solidFill>
-                  </a:tcPr>
-                </a:tc>
-                <a:tc>
-                  <a:txBody>
-                    <a:bodyPr/>
-                    <a:lstStyle/>
-                    <a:p>
-                      <a:pPr>
-                        <a:defRPr sz="1400">
-                          <a:solidFill>
-                            <a:srgbClr val="0F172A"/>
-                          </a:solidFill>
-                          <a:latin typeface="Calibri"/>
-                        </a:defRPr>
-                      </a:pPr>
-                      <a:r>
-                        <a:t>Submit structural justification, rebar repair details, and CAPA for Consultant review; hold further works.</a:t>
-                      </a:r>
-                    </a:p>
-                  </a:txBody>
-                  <a:tcPr anchor="ctr">
-                    <a:solidFill>
-                      <a:srgbClr val="FFFFFF"/>
-                    </a:solidFill>
-                  </a:tcPr>
-                </a:tc>
-                <a:tc>
-                  <a:txBody>
-                    <a:bodyPr/>
-                    <a:lstStyle/>
-                    <a:p>
-                      <a:pPr algn="ctr">
-                        <a:defRPr sz="1400" b="1">
-                          <a:solidFill>
-                            <a:srgbClr val="0F172A"/>
-                          </a:solidFill>
-                          <a:latin typeface="Calibri"/>
-                        </a:defRPr>
-                      </a:pPr>
-                      <a:r>
-                        <a:t>2026-08-20</a:t>
-                      </a:r>
-                    </a:p>
-                  </a:txBody>
-                  <a:tcPr anchor="ctr">
-                    <a:solidFill>
-                      <a:srgbClr val="FFFFFF"/>
-                    </a:solidFill>
-                  </a:tcPr>
-                </a:tc>
-                <a:tc>
-                  <a:txBody>
-                    <a:bodyPr/>
-                    <a:lstStyle/>
-                    <a:p>
-                      <a:pPr algn="ctr">
-                        <a:defRPr sz="2200" b="1">
-                          <a:solidFill>
-                            <a:srgbClr val="0F172A"/>
-                          </a:solidFill>
-                          <a:latin typeface="Calibri"/>
-                        </a:defRPr>
-                      </a:pPr>
-                      <a:r>
-                        <a:t>18 d</a:t>
-                      </a:r>
-                    </a:p>
-                    <a:p>
-                      <a:pPr algn="ctr">
-                        <a:defRPr sz="1200">
-                          <a:solidFill>
-                            <a:srgbClr val="64748B"/>
-                          </a:solidFill>
-                          <a:latin typeface="Calibri"/>
-                        </a:defRPr>
-                      </a:pPr>
-                      <a:r>
-                        <a:t>[&lt; 2 Months]</a:t>
-                      </a:r>
-                    </a:p>
-                  </a:txBody>
-                  <a:tcPr anchor="ctr">
-                    <a:solidFill>
-                      <a:srgbClr val="FFFFFF"/>
-                    </a:solidFill>
-                  </a:tcPr>
-                </a:tc>
-                <a:tc>
-                  <a:txBody>
-                    <a:bodyPr/>
-                    <a:lstStyle/>
-                    <a:p>
-                      <a:pPr>
-                        <a:defRPr sz="1400">
-                          <a:solidFill>
-                            <a:srgbClr val="0F172A"/>
-                          </a:solidFill>
-                          <a:latin typeface="Calibri"/>
-                        </a:defRPr>
-                      </a:pPr>
-                      <a:r>
-                        <a:rPr dirty="0"/>
-                        <a:t>CAPA Approved (Code B on 24-Aug) — Rebar repair completed</a:t>
-                      </a:r>
-                      <a:r>
-                        <a:rPr lang="en-US" dirty="0"/>
-                        <a:t>. Waiting for </a:t>
-                      </a:r>
-                      <a:r>
-                        <a:rPr lang="en-US" dirty="0" err="1"/>
-                        <a:t>drwg</a:t>
-                      </a:r>
-                      <a:r>
-                        <a:rPr lang="en-US" dirty="0"/>
-                        <a:t> for technical</a:t>
-                      </a:r>
-                      <a:endParaRPr dirty="0"/>
+                        <a:t>CAPA will be submitted</a:t>
+                      </a:r>
                     </a:p>
                   </a:txBody>
                   <a:tcPr anchor="ctr">
@@ -8052,14 +8029,14 @@
           <p:nvPr>
             <p:extLst>
               <p:ext uri="{D42A27DB-BD31-4B8C-83A1-F6EECF244321}">
-                <p14:modId xmlns:p14="http://schemas.microsoft.com/office/powerpoint/2010/main" val="1866236041"/>
+                <p14:modId xmlns:p14="http://schemas.microsoft.com/office/powerpoint/2010/main" val="4289913940"/>
               </p:ext>
             </p:extLst>
           </p:nvPr>
         </p:nvGraphicFramePr>
         <p:xfrm>
           <a:off x="457200" y="411480"/>
-          <a:ext cx="11401865" cy="6141717"/>
+          <a:ext cx="11277295" cy="6141717"/>
         </p:xfrm>
         <a:graphic>
           <a:graphicData uri="http://schemas.openxmlformats.org/drawingml/2006/table">
@@ -8068,49 +8045,49 @@
                 <a:tableStyleId>{5C22544A-7EE6-4342-B048-85BDC9FD1C3A}</a:tableStyleId>
               </a:tblPr>
               <a:tblGrid>
-                <a:gridCol w="508475">
+                <a:gridCol w="502920">
                   <a:extLst>
                     <a:ext uri="{9D8B030D-6E8A-4147-A177-3AD203B41FA5}">
                       <a16:colId xmlns:a16="http://schemas.microsoft.com/office/drawing/2014/main" val="20000"/>
                     </a:ext>
                   </a:extLst>
                 </a:gridCol>
-                <a:gridCol w="2033901">
+                <a:gridCol w="2011680">
                   <a:extLst>
                     <a:ext uri="{9D8B030D-6E8A-4147-A177-3AD203B41FA5}">
                       <a16:colId xmlns:a16="http://schemas.microsoft.com/office/drawing/2014/main" val="20001"/>
                     </a:ext>
                   </a:extLst>
                 </a:gridCol>
-                <a:gridCol w="2588602">
+                <a:gridCol w="2560320">
                   <a:extLst>
                     <a:ext uri="{9D8B030D-6E8A-4147-A177-3AD203B41FA5}">
                       <a16:colId xmlns:a16="http://schemas.microsoft.com/office/drawing/2014/main" val="20002"/>
                     </a:ext>
                   </a:extLst>
                 </a:gridCol>
-                <a:gridCol w="2496151">
+                <a:gridCol w="2468880">
                   <a:extLst>
                     <a:ext uri="{9D8B030D-6E8A-4147-A177-3AD203B41FA5}">
                       <a16:colId xmlns:a16="http://schemas.microsoft.com/office/drawing/2014/main" val="20003"/>
                     </a:ext>
                   </a:extLst>
                 </a:gridCol>
-                <a:gridCol w="1016951">
+                <a:gridCol w="1005840">
                   <a:extLst>
                     <a:ext uri="{9D8B030D-6E8A-4147-A177-3AD203B41FA5}">
                       <a16:colId xmlns:a16="http://schemas.microsoft.com/office/drawing/2014/main" val="20004"/>
                     </a:ext>
                   </a:extLst>
                 </a:gridCol>
-                <a:gridCol w="1063176">
+                <a:gridCol w="1051560">
                   <a:extLst>
                     <a:ext uri="{9D8B030D-6E8A-4147-A177-3AD203B41FA5}">
                       <a16:colId xmlns:a16="http://schemas.microsoft.com/office/drawing/2014/main" val="20005"/>
                     </a:ext>
                   </a:extLst>
                 </a:gridCol>
-                <a:gridCol w="1694609">
+                <a:gridCol w="1676095">
                   <a:extLst>
                     <a:ext uri="{9D8B030D-6E8A-4147-A177-3AD203B41FA5}">
                       <a16:colId xmlns:a16="http://schemas.microsoft.com/office/drawing/2014/main" val="20006"/>
@@ -8336,7 +8313,7 @@
                       </a:r>
                       <a:br/>
                       <a:r>
-                        <a:t>SOA-NCR-QL-000039</a:t>
+                        <a:t>SOA-NCR-QL-000041</a:t>
                       </a:r>
                     </a:p>
                     <a:p>
@@ -8349,7 +8326,7 @@
                         </a:defRPr>
                       </a:pPr>
                       <a:r>
-                        <a:t>Façade (Façade Mockup)</a:t>
+                        <a:t>Civil / Material (Rebar Laydown)</a:t>
                       </a:r>
                     </a:p>
                   </a:txBody>
@@ -8373,7 +8350,16 @@
                         </a:defRPr>
                       </a:pPr>
                       <a:r>
-                        <a:t>JANGHO unauthorized welding on Façade Mockup: no approved WPS, uncertified welders, non-compliant with AWS D1.1.</a:t>
+                        <a:rPr dirty="0"/>
+                        <a:t>Unapproved Grade 80 Steel delivered to site from Al-</a:t>
+                      </a:r>
+                      <a:r>
+                        <a:rPr dirty="0" err="1"/>
+                        <a:t>Ittefaq</a:t>
+                      </a:r>
+                      <a:r>
+                        <a:rPr dirty="0"/>
+                        <a:t> Steel without approved MAR/MIR (both currently Code-C).</a:t>
                       </a:r>
                     </a:p>
                   </a:txBody>
@@ -8397,7 +8383,7 @@
                         </a:defRPr>
                       </a:pPr>
                       <a:r>
-                        <a:t>Suspended welding works; submit WPS, welder qualification records, calibration certificates, and Welding MS &amp; ITP.</a:t>
+                        <a:t>Quarantined delivered steel; enforce strict no-use policy until formal approval or removal from site; submit preventive plan.</a:t>
                       </a:r>
                     </a:p>
                   </a:txBody>
@@ -8421,7 +8407,7 @@
                         </a:defRPr>
                       </a:pPr>
                       <a:r>
-                        <a:t>2026-08-20</a:t>
+                        <a:t>2026-08-25</a:t>
                       </a:r>
                     </a:p>
                   </a:txBody>
@@ -8445,12 +8431,12 @@
                         </a:defRPr>
                       </a:pPr>
                       <a:r>
-                        <a:t>18 d</a:t>
-                      </a:r>
-                    </a:p>
-                    <a:p>
-                      <a:pPr algn="ctr">
-                        <a:defRPr sz="1200">
+                        <a:t>22 d</a:t>
+                      </a:r>
+                    </a:p>
+                    <a:p>
+                      <a:pPr algn="ctr">
+                        <a:defRPr sz="1200" b="1">
                           <a:solidFill>
                             <a:srgbClr val="64748B"/>
                           </a:solidFill>
@@ -8483,11 +8469,19 @@
                       </a:pPr>
                       <a:r>
                         <a:rPr dirty="0"/>
-                        <a:t>NDT inspection completed on 3rd Sep; welder qualification package under final compilation.</a:t>
+                        <a:t>Material quarantined on site, </a:t>
                       </a:r>
                       <a:r>
                         <a:rPr lang="en-US" dirty="0"/>
-                        <a:t> WPS, MAT, MST(UR)</a:t>
+                        <a:t>material will be removed from site by 24</a:t>
+                      </a:r>
+                      <a:r>
+                        <a:rPr lang="en-US" baseline="30000" dirty="0"/>
+                        <a:t>th</a:t>
+                      </a:r>
+                      <a:r>
+                        <a:rPr lang="en-US" dirty="0"/>
+                        <a:t> Sep</a:t>
                       </a:r>
                       <a:endParaRPr dirty="0"/>
                     </a:p>
@@ -8543,15 +8537,11 @@
                         </a:defRPr>
                       </a:pPr>
                       <a:r>
-                        <a:rPr dirty="0"/>
                         <a:t>BV-BSW-105-0000-</a:t>
                       </a:r>
-                      <a:br>
-                        <a:rPr dirty="0"/>
-                      </a:br>
-                      <a:r>
-                        <a:rPr dirty="0"/>
-                        <a:t>SOA-NCR-QL-000040</a:t>
+                      <a:br/>
+                      <a:r>
+                        <a:t>SOA-NCR-QL-000042</a:t>
                       </a:r>
                     </a:p>
                     <a:p>
@@ -8564,8 +8554,7 @@
                         </a:defRPr>
                       </a:pPr>
                       <a:r>
-                        <a:rPr dirty="0"/>
-                        <a:t>Documentation / QA/QC KPI</a:t>
+                        <a:t>Civil (Zone 9 B1 Joint)</a:t>
                       </a:r>
                     </a:p>
                   </a:txBody>
@@ -8589,8 +8578,7 @@
                         </a:defRPr>
                       </a:pPr>
                       <a:r>
-                        <a:rPr dirty="0"/>
-                        <a:t>High Code C rate on Material Submittals (84 submittals at Code C; KPI &lt; 70% vs mandatory 90% project requirement).</a:t>
+                        <a:t>Repeated non-compliance: formwork removed at construction joint at Zone 9 B1. Edge shutter stripped prematurely.</a:t>
                       </a:r>
                     </a:p>
                   </a:txBody>
@@ -8614,7 +8602,7 @@
                         </a:defRPr>
                       </a:pPr>
                       <a:r>
-                        <a:t>Enforce strict internal technical QA/QC review; withdraw non-applicable submittals; submit recovery plan to reach 90% KPI.</a:t>
+                        <a:t>Halt premature formwork stripping; reinstate edge shutter support; inspect joint face and submit method statement.</a:t>
                       </a:r>
                     </a:p>
                   </a:txBody>
@@ -8638,7 +8626,7 @@
                         </a:defRPr>
                       </a:pPr>
                       <a:r>
-                        <a:t>2026-08-25</a:t>
+                        <a:t>2026-08-27</a:t>
                       </a:r>
                     </a:p>
                   </a:txBody>
@@ -8662,12 +8650,12 @@
                         </a:defRPr>
                       </a:pPr>
                       <a:r>
-                        <a:t>13 d</a:t>
-                      </a:r>
-                    </a:p>
-                    <a:p>
-                      <a:pPr algn="ctr">
-                        <a:defRPr sz="1200">
+                        <a:t>20 d</a:t>
+                      </a:r>
+                    </a:p>
+                    <a:p>
+                      <a:pPr algn="ctr">
+                        <a:defRPr sz="1200" b="1">
                           <a:solidFill>
                             <a:srgbClr val="64748B"/>
                           </a:solidFill>
@@ -8690,7 +8678,21 @@
                     <a:bodyPr/>
                     <a:lstStyle/>
                     <a:p>
-                      <a:pPr>
+                      <a:pPr marL="0" marR="0" lvl="0" indent="0" algn="l" defTabSz="457200" rtl="0" eaLnBrk="1" fontAlgn="auto" latinLnBrk="0" hangingPunct="1">
+                        <a:lnSpc>
+                          <a:spcPct val="100000"/>
+                        </a:lnSpc>
+                        <a:spcBef>
+                          <a:spcPts val="0"/>
+                        </a:spcBef>
+                        <a:spcAft>
+                          <a:spcPts val="0"/>
+                        </a:spcAft>
+                        <a:buClrTx/>
+                        <a:buSzTx/>
+                        <a:buFontTx/>
+                        <a:buNone/>
+                        <a:tabLst/>
                         <a:defRPr sz="1400">
                           <a:solidFill>
                             <a:srgbClr val="0F172A"/>
@@ -8699,8 +8701,12 @@
                         </a:defRPr>
                       </a:pPr>
                       <a:r>
-                        <a:rPr lang="en-US" dirty="0"/>
-                        <a:t>CAPA will be submitted</a:t>
+                        <a:rPr lang="en-US" dirty="0">
+                          <a:solidFill>
+                            <a:srgbClr val="FFC000"/>
+                          </a:solidFill>
+                        </a:rPr>
+                        <a:t>Close out submitted</a:t>
                       </a:r>
                       <a:endParaRPr dirty="0"/>
                     </a:p>
@@ -8760,7 +8766,7 @@
                       </a:r>
                       <a:br/>
                       <a:r>
-                        <a:t>SOA-NCR-QL-000041</a:t>
+                        <a:t>SOA-NCR-QL-000043</a:t>
                       </a:r>
                     </a:p>
                     <a:p>
@@ -8773,7 +8779,7 @@
                         </a:defRPr>
                       </a:pPr>
                       <a:r>
-                        <a:t>Civil / Material (Rebar Laydown)</a:t>
+                        <a:t>Civil (Slab Zone 9 B1)</a:t>
                       </a:r>
                     </a:p>
                   </a:txBody>
@@ -8797,16 +8803,7 @@
                         </a:defRPr>
                       </a:pPr>
                       <a:r>
-                        <a:rPr dirty="0"/>
-                        <a:t>Unapproved Grade 80 Steel delivered to site from Al-</a:t>
-                      </a:r>
-                      <a:r>
-                        <a:rPr dirty="0" err="1"/>
-                        <a:t>Ittefaq</a:t>
-                      </a:r>
-                      <a:r>
-                        <a:rPr dirty="0"/>
-                        <a:t> Steel without approved MAR/MIR (both currently Code-C).</a:t>
+                        <a:t>Unacceptable concrete quality and ineffective preventive measures on slab at Zone 9 B1: surface voids and uneven finish.</a:t>
                       </a:r>
                     </a:p>
                   </a:txBody>
@@ -8830,7 +8827,7 @@
                         </a:defRPr>
                       </a:pPr>
                       <a:r>
-                        <a:t>Quarantined delivered steel; enforce strict no-use policy until formal approval or removal from site; submit preventive plan.</a:t>
+                        <a:t>Perform thorough concrete defect mapping, core testing/NDT if requested; submit remedial method statement and controls.</a:t>
                       </a:r>
                     </a:p>
                   </a:txBody>
@@ -8854,7 +8851,7 @@
                         </a:defRPr>
                       </a:pPr>
                       <a:r>
-                        <a:t>2026-08-25</a:t>
+                        <a:t>2026-08-30</a:t>
                       </a:r>
                     </a:p>
                   </a:txBody>
@@ -8878,12 +8875,12 @@
                         </a:defRPr>
                       </a:pPr>
                       <a:r>
-                        <a:t>13 d</a:t>
-                      </a:r>
-                    </a:p>
-                    <a:p>
-                      <a:pPr algn="ctr">
-                        <a:defRPr sz="1200">
+                        <a:t>17 d</a:t>
+                      </a:r>
+                    </a:p>
+                    <a:p>
+                      <a:pPr algn="ctr">
+                        <a:defRPr sz="1200" b="1">
                           <a:solidFill>
                             <a:srgbClr val="64748B"/>
                           </a:solidFill>
@@ -8915,26 +8912,10 @@
                         </a:defRPr>
                       </a:pPr>
                       <a:r>
-                        <a:rPr dirty="0">
-                          <a:solidFill>
-                            <a:srgbClr val="00B050"/>
-                          </a:solidFill>
-                        </a:rPr>
-                        <a:t>Material quarantined on site, NCR </a:t>
-                      </a:r>
-                      <a:r>
-                        <a:rPr lang="en-US" dirty="0">
-                          <a:solidFill>
-                            <a:srgbClr val="00B050"/>
-                          </a:solidFill>
-                        </a:rPr>
-                        <a:t>closing to be discussed</a:t>
-                      </a:r>
-                      <a:endParaRPr dirty="0">
-                        <a:solidFill>
-                          <a:srgbClr val="00B050"/>
-                        </a:solidFill>
-                      </a:endParaRPr>
+                        <a:rPr lang="en-US" dirty="0"/>
+                        <a:t>Test report has been submitted</a:t>
+                      </a:r>
+                      <a:endParaRPr dirty="0"/>
                     </a:p>
                   </a:txBody>
                   <a:tcPr anchor="ctr">
@@ -9031,7 +9012,7 @@
           <p:nvPr>
             <p:extLst>
               <p:ext uri="{D42A27DB-BD31-4B8C-83A1-F6EECF244321}">
-                <p14:modId xmlns:p14="http://schemas.microsoft.com/office/powerpoint/2010/main" val="4110562710"/>
+                <p14:modId xmlns:p14="http://schemas.microsoft.com/office/powerpoint/2010/main" val="1284526538"/>
               </p:ext>
             </p:extLst>
           </p:nvPr>
@@ -9315,7 +9296,7 @@
                       </a:r>
                       <a:br/>
                       <a:r>
-                        <a:t>SOA-NCR-QL-000042</a:t>
+                        <a:t>SOA-NCR-QL-000044</a:t>
                       </a:r>
                     </a:p>
                     <a:p>
@@ -9328,7 +9309,7 @@
                         </a:defRPr>
                       </a:pPr>
                       <a:r>
-                        <a:t>Civil (Zone 9 B1 Joint)</a:t>
+                        <a:t>Quality / Documentation</a:t>
                       </a:r>
                     </a:p>
                   </a:txBody>
@@ -9352,7 +9333,7 @@
                         </a:defRPr>
                       </a:pPr>
                       <a:r>
-                        <a:t>Repeated non-compliance: formwork removed at construction joint at Zone 9 B1. Edge shutter stripped prematurely.</a:t>
+                        <a:t>NEW: Low NCR Closure KPI and Overdue NCRs: Issued by Client/Consultant due to slow closeout turnaround and accumulated overdue items.</a:t>
                       </a:r>
                     </a:p>
                   </a:txBody>
@@ -9376,7 +9357,7 @@
                         </a:defRPr>
                       </a:pPr>
                       <a:r>
-                        <a:t>Halt premature formwork stripping; reinstate edge shutter support; inspect joint face and submit method statement.</a:t>
+                        <a:t>Formulate and submit an immediate, high-priority NCR Recovery Plan; mobilize dedicated technical engineers to close pending items.</a:t>
                       </a:r>
                     </a:p>
                   </a:txBody>
@@ -9400,7 +9381,7 @@
                         </a:defRPr>
                       </a:pPr>
                       <a:r>
-                        <a:t>2026-08-27</a:t>
+                        <a:t>2026-09-06</a:t>
                       </a:r>
                     </a:p>
                   </a:txBody>
@@ -9424,12 +9405,12 @@
                         </a:defRPr>
                       </a:pPr>
                       <a:r>
-                        <a:t>11 d</a:t>
-                      </a:r>
-                    </a:p>
-                    <a:p>
-                      <a:pPr algn="ctr">
-                        <a:defRPr sz="1200">
+                        <a:t>10 d</a:t>
+                      </a:r>
+                    </a:p>
+                    <a:p>
+                      <a:pPr algn="ctr">
+                        <a:defRPr sz="1200" b="1">
                           <a:solidFill>
                             <a:srgbClr val="64748B"/>
                           </a:solidFill>
@@ -9462,21 +9443,8 @@
                       </a:pPr>
                       <a:r>
                         <a:rPr dirty="0"/>
-                        <a:t>CAPA</a:t>
-                      </a:r>
-                      <a:r>
-                        <a:rPr lang="en-US" dirty="0"/>
-                        <a:t> will submit today</a:t>
-                      </a:r>
-                      <a:r>
-                        <a:rPr dirty="0"/>
-                        <a:t>) — Edge shutter reinstated; </a:t>
-                      </a:r>
-                      <a:r>
-                        <a:rPr lang="en-US" dirty="0"/>
-                        <a:t>construction joint method statement drafted.</a:t>
-                      </a:r>
-                      <a:endParaRPr dirty="0"/>
+                        <a:t>NCR closing on-going process. Closing to be discussed</a:t>
+                      </a:r>
                     </a:p>
                   </a:txBody>
                   <a:tcPr anchor="ctr">
@@ -9530,11 +9498,15 @@
                         </a:defRPr>
                       </a:pPr>
                       <a:r>
+                        <a:rPr dirty="0"/>
                         <a:t>BV-BSW-105-0000-</a:t>
                       </a:r>
-                      <a:br/>
-                      <a:r>
-                        <a:t>SOA-NCR-QL-000043</a:t>
+                      <a:br>
+                        <a:rPr dirty="0"/>
+                      </a:br>
+                      <a:r>
+                        <a:rPr dirty="0"/>
+                        <a:t>SOA-NCR-QL-000045</a:t>
                       </a:r>
                     </a:p>
                     <a:p>
@@ -9547,7 +9519,8 @@
                         </a:defRPr>
                       </a:pPr>
                       <a:r>
-                        <a:t>Civil (Slab Zone 9 B1)</a:t>
+                        <a:rPr dirty="0"/>
+                        <a:t>Civil (Zone 5)</a:t>
                       </a:r>
                     </a:p>
                   </a:txBody>
@@ -9571,7 +9544,7 @@
                         </a:defRPr>
                       </a:pPr>
                       <a:r>
-                        <a:t>Unacceptable concrete quality and ineffective preventive measures on slab at Zone 9 B1: surface voids and uneven finish.</a:t>
+                        <a:t>NEW: Unauthorized cutting/welding of non-weldable structural reinforcement bars and unauthorized concrete demolition works in Zone 5.</a:t>
                       </a:r>
                     </a:p>
                   </a:txBody>
@@ -9595,7 +9568,7 @@
                         </a:defRPr>
                       </a:pPr>
                       <a:r>
-                        <a:t>Perform thorough concrete defect mapping, core testing/NDT if requested; submit remedial method statement and controls.</a:t>
+                        <a:t>Immediately cease cutting/welding &amp; demolition in Zone 5; submit structural damage evaluation and rebar reinstatement MS.</a:t>
                       </a:r>
                     </a:p>
                   </a:txBody>
@@ -9619,7 +9592,7 @@
                         </a:defRPr>
                       </a:pPr>
                       <a:r>
-                        <a:t>2026-08-30</a:t>
+                        <a:t>2026-09-06</a:t>
                       </a:r>
                     </a:p>
                   </a:txBody>
@@ -9643,12 +9616,12 @@
                         </a:defRPr>
                       </a:pPr>
                       <a:r>
-                        <a:t>8 d</a:t>
-                      </a:r>
-                    </a:p>
-                    <a:p>
-                      <a:pPr algn="ctr">
-                        <a:defRPr sz="1200">
+                        <a:t>10 d</a:t>
+                      </a:r>
+                    </a:p>
+                    <a:p>
+                      <a:pPr algn="ctr">
+                        <a:defRPr sz="1200" b="1">
                           <a:solidFill>
                             <a:srgbClr val="64748B"/>
                           </a:solidFill>
@@ -9685,23 +9658,7 @@
                             <a:srgbClr val="FFC000"/>
                           </a:solidFill>
                         </a:rPr>
-                        <a:t>3</a:t>
-                      </a:r>
-                      <a:r>
-                        <a:rPr lang="en-US" baseline="30000" dirty="0">
-                          <a:solidFill>
-                            <a:srgbClr val="FFC000"/>
-                          </a:solidFill>
-                        </a:rPr>
-                        <a:t>rd</a:t>
-                      </a:r>
-                      <a:r>
-                        <a:rPr lang="en-US" dirty="0">
-                          <a:solidFill>
-                            <a:srgbClr val="FFC000"/>
-                          </a:solidFill>
-                        </a:rPr>
-                        <a:t> party test done, waiting for report</a:t>
+                        <a:t>CAPA proposal has been submitted</a:t>
                       </a:r>
                       <a:endParaRPr dirty="0">
                         <a:solidFill>
@@ -9765,7 +9722,7 @@
                       </a:r>
                       <a:br/>
                       <a:r>
-                        <a:t>SOA-NCR-QL-000044</a:t>
+                        <a:t>SOA-NCR-QL-000046</a:t>
                       </a:r>
                     </a:p>
                     <a:p>
@@ -9778,7 +9735,7 @@
                         </a:defRPr>
                       </a:pPr>
                       <a:r>
-                        <a:t>Quality / Documentation</a:t>
+                        <a:t>Architectural (Zone 11 B2)</a:t>
                       </a:r>
                     </a:p>
                   </a:txBody>
@@ -9802,7 +9759,7 @@
                         </a:defRPr>
                       </a:pPr>
                       <a:r>
-                        <a:t>NEW: Low NCR Closure KPI and Overdue NCRs: Issued by Client/Consultant due to slow closeout turnaround and accumulated overdue items.</a:t>
+                        <a:t>NEW: Persistent and uncontrolled non-compliance with SF3 fair-faced architectural concrete finish requirements at Zone 11 (B2 level).</a:t>
                       </a:r>
                     </a:p>
                   </a:txBody>
@@ -9826,7 +9783,7 @@
                         </a:defRPr>
                       </a:pPr>
                       <a:r>
-                        <a:t>Formulate and submit an immediate, high-priority NCR Recovery Plan; mobilize dedicated technical engineers to close pending items.</a:t>
+                        <a:t>Stop concreting in Zone 11 fair-faced elements until formwork quality and placement practices are audited; submit detailed CAPA.</a:t>
                       </a:r>
                     </a:p>
                   </a:txBody>
@@ -9850,7 +9807,7 @@
                         </a:defRPr>
                       </a:pPr>
                       <a:r>
-                        <a:t>2026-09-06</a:t>
+                        <a:t>2026-09-07</a:t>
                       </a:r>
                     </a:p>
                   </a:txBody>
@@ -9874,12 +9831,12 @@
                         </a:defRPr>
                       </a:pPr>
                       <a:r>
-                        <a:t>1 d</a:t>
-                      </a:r>
-                    </a:p>
-                    <a:p>
-                      <a:pPr algn="ctr">
-                        <a:defRPr sz="1200">
+                        <a:t>9 d</a:t>
+                      </a:r>
+                    </a:p>
+                    <a:p>
+                      <a:pPr algn="ctr">
+                        <a:defRPr sz="1200" b="1">
                           <a:solidFill>
                             <a:srgbClr val="64748B"/>
                           </a:solidFill>
@@ -9911,14 +9868,14 @@
                         </a:defRPr>
                       </a:pPr>
                       <a:r>
-                        <a:rPr lang="en-US" dirty="0">
+                        <a:rPr lang="en-US" sz="1200" b="0" dirty="0">
                           <a:solidFill>
                             <a:srgbClr val="FFC000"/>
                           </a:solidFill>
                         </a:rPr>
-                        <a:t>NCR closing on-going process. Closing to be discussed</a:t>
-                      </a:r>
-                      <a:endParaRPr dirty="0">
+                        <a:t>Test is done, report is submitted, repair will be planned</a:t>
+                      </a:r>
+                      <a:endParaRPr sz="1200" b="0" dirty="0">
                         <a:solidFill>
                           <a:srgbClr val="FFC000"/>
                         </a:solidFill>
@@ -10019,14 +9976,14 @@
           <p:nvPr>
             <p:extLst>
               <p:ext uri="{D42A27DB-BD31-4B8C-83A1-F6EECF244321}">
-                <p14:modId xmlns:p14="http://schemas.microsoft.com/office/powerpoint/2010/main" val="22818570"/>
+                <p14:modId xmlns:p14="http://schemas.microsoft.com/office/powerpoint/2010/main" val="1162059789"/>
               </p:ext>
             </p:extLst>
           </p:nvPr>
         </p:nvGraphicFramePr>
         <p:xfrm>
           <a:off x="457200" y="411480"/>
-          <a:ext cx="11277295" cy="6096000"/>
+          <a:ext cx="11277295" cy="6141717"/>
         </p:xfrm>
         <a:graphic>
           <a:graphicData uri="http://schemas.openxmlformats.org/drawingml/2006/table">
@@ -10260,7 +10217,7 @@
                   </a:ext>
                 </a:extLst>
               </a:tr>
-              <a:tr h="2788920">
+              <a:tr h="1874519">
                 <a:tc>
                   <a:txBody>
                     <a:bodyPr/>
@@ -10303,7 +10260,7 @@
                       </a:r>
                       <a:br/>
                       <a:r>
-                        <a:t>SOA-NCR-QL-000045</a:t>
+                        <a:t>SOA-NCR-QL-000047</a:t>
                       </a:r>
                     </a:p>
                     <a:p>
@@ -10316,7 +10273,7 @@
                         </a:defRPr>
                       </a:pPr>
                       <a:r>
-                        <a:t>Civil (Zone 5)</a:t>
+                        <a:t>Civil (Zone 1 B1)</a:t>
                       </a:r>
                     </a:p>
                   </a:txBody>
@@ -10340,7 +10297,7 @@
                         </a:defRPr>
                       </a:pPr>
                       <a:r>
-                        <a:t>NEW: Unauthorized cutting/welding of non-weldable structural reinforcement bars and unauthorized concrete demolition works in Zone 5.</a:t>
+                        <a:t>NEW: Unauthorized concrete chipping and improper concrete cover rectification works observed at Zone 1 (B1 level).</a:t>
                       </a:r>
                     </a:p>
                   </a:txBody>
@@ -10364,7 +10321,7 @@
                         </a:defRPr>
                       </a:pPr>
                       <a:r>
-                        <a:t>Immediately cease cutting/welding &amp; demolition in Zone 5; submit structural damage evaluation and rebar reinstatement MS.</a:t>
+                        <a:t>Cease unauthorized chipping; submit structural assessment, approved repair method statement, and WIR for cover rectification.</a:t>
                       </a:r>
                     </a:p>
                   </a:txBody>
@@ -10388,7 +10345,7 @@
                         </a:defRPr>
                       </a:pPr>
                       <a:r>
-                        <a:t>2026-09-06</a:t>
+                        <a:t>2026-09-08</a:t>
                       </a:r>
                     </a:p>
                   </a:txBody>
@@ -10412,12 +10369,12 @@
                         </a:defRPr>
                       </a:pPr>
                       <a:r>
-                        <a:t>1 d</a:t>
-                      </a:r>
-                    </a:p>
-                    <a:p>
-                      <a:pPr algn="ctr">
-                        <a:defRPr sz="1200">
+                        <a:t>8 d</a:t>
+                      </a:r>
+                    </a:p>
+                    <a:p>
+                      <a:pPr algn="ctr">
+                        <a:defRPr sz="1200" b="1">
                           <a:solidFill>
                             <a:srgbClr val="64748B"/>
                           </a:solidFill>
@@ -10450,7 +10407,11 @@
                       </a:pPr>
                       <a:r>
                         <a:rPr lang="en-US" dirty="0"/>
-                        <a:t>Dowels have been removed, reinstallation on-going</a:t>
+                        <a:t>CAPA has </a:t>
+                      </a:r>
+                      <a:r>
+                        <a:rPr lang="en-US"/>
+                        <a:t>been submitted</a:t>
                       </a:r>
                       <a:endParaRPr dirty="0"/>
                     </a:p>
@@ -10467,7 +10428,7 @@
                   </a:ext>
                 </a:extLst>
               </a:tr>
-              <a:tr h="2788920">
+              <a:tr h="1874519">
                 <a:tc>
                   <a:txBody>
                     <a:bodyPr/>
@@ -10510,7 +10471,7 @@
                       </a:r>
                       <a:br/>
                       <a:r>
-                        <a:t>SOA-NCR-QL-000046</a:t>
+                        <a:t>SOA-NCR-QL-000048</a:t>
                       </a:r>
                     </a:p>
                     <a:p>
@@ -10523,7 +10484,7 @@
                         </a:defRPr>
                       </a:pPr>
                       <a:r>
-                        <a:t>Architectural (Zone 11 B2)</a:t>
+                        <a:t>Civil (Zone 1 L0 to L2)</a:t>
                       </a:r>
                     </a:p>
                   </a:txBody>
@@ -10547,8 +10508,7 @@
                         </a:defRPr>
                       </a:pPr>
                       <a:r>
-                        <a:rPr dirty="0"/>
-                        <a:t>NEW: Persistent and uncontrolled non-compliance with SF3 fair-faced architectural concrete finish requirements at Zone 11 (B2 level).</a:t>
+                        <a:t>NEW: Significant wall verticality deviation noted from Level L0 to L2 in Zone 1, followed by unauthorized cosmetic repair.</a:t>
                       </a:r>
                     </a:p>
                   </a:txBody>
@@ -10572,7 +10532,7 @@
                         </a:defRPr>
                       </a:pPr>
                       <a:r>
-                        <a:t>Stop concreting in Zone 11 fair-faced elements until formwork quality and placement practices are audited; submit detailed CAPA.</a:t>
+                        <a:t>Conduct comprehensive 3D laser survey for verticality deviation; submit structural integrity assessment and remedial plan to CSC.</a:t>
                       </a:r>
                     </a:p>
                   </a:txBody>
@@ -10596,7 +10556,7 @@
                         </a:defRPr>
                       </a:pPr>
                       <a:r>
-                        <a:t>2026-09-07</a:t>
+                        <a:t>2026-09-09</a:t>
                       </a:r>
                     </a:p>
                   </a:txBody>
@@ -10620,12 +10580,12 @@
                         </a:defRPr>
                       </a:pPr>
                       <a:r>
-                        <a:t>0 d</a:t>
-                      </a:r>
-                    </a:p>
-                    <a:p>
-                      <a:pPr algn="ctr">
-                        <a:defRPr sz="1200">
+                        <a:t>7 d</a:t>
+                      </a:r>
+                    </a:p>
+                    <a:p>
+                      <a:pPr algn="ctr">
+                        <a:defRPr sz="1200" b="1">
                           <a:solidFill>
                             <a:srgbClr val="64748B"/>
                           </a:solidFill>
@@ -10657,10 +10617,8 @@
                         </a:defRPr>
                       </a:pPr>
                       <a:r>
-                        <a:rPr lang="en-US" dirty="0"/>
-                        <a:t>CAPA will be submitted, formwork will be installed and grouting will be done</a:t>
-                      </a:r>
-                      <a:endParaRPr dirty="0"/>
+                        <a:t>Open (Awaiting CAPA) — Survey report being finalized; structural evaluation underway.</a:t>
+                      </a:r>
                     </a:p>
                   </a:txBody>
                   <a:tcPr anchor="ctr">
@@ -10672,6 +10630,212 @@
                 <a:extLst>
                   <a:ext uri="{0D108BD9-81ED-4DB2-BD59-A6C34878D82A}">
                     <a16:rowId xmlns:a16="http://schemas.microsoft.com/office/drawing/2014/main" val="10002"/>
+                  </a:ext>
+                </a:extLst>
+              </a:tr>
+              <a:tr h="1874519">
+                <a:tc>
+                  <a:txBody>
+                    <a:bodyPr/>
+                    <a:lstStyle/>
+                    <a:p>
+                      <a:pPr algn="ctr">
+                        <a:defRPr sz="2200" b="1">
+                          <a:solidFill>
+                            <a:srgbClr val="0F172A"/>
+                          </a:solidFill>
+                          <a:latin typeface="Calibri"/>
+                        </a:defRPr>
+                      </a:pPr>
+                      <a:r>
+                        <a:t>24</a:t>
+                      </a:r>
+                    </a:p>
+                  </a:txBody>
+                  <a:tcPr anchor="ctr">
+                    <a:solidFill>
+                      <a:srgbClr val="FFFFFF"/>
+                    </a:solidFill>
+                  </a:tcPr>
+                </a:tc>
+                <a:tc>
+                  <a:txBody>
+                    <a:bodyPr/>
+                    <a:lstStyle/>
+                    <a:p>
+                      <a:pPr>
+                        <a:defRPr sz="1400" b="1">
+                          <a:solidFill>
+                            <a:srgbClr val="0F2444"/>
+                          </a:solidFill>
+                          <a:latin typeface="Calibri"/>
+                        </a:defRPr>
+                      </a:pPr>
+                      <a:r>
+                        <a:t>BV-BSW-105-0000-</a:t>
+                      </a:r>
+                      <a:br/>
+                      <a:r>
+                        <a:t>SOA-NCR-QL-000049</a:t>
+                      </a:r>
+                    </a:p>
+                    <a:p>
+                      <a:pPr>
+                        <a:defRPr sz="1400" b="1">
+                          <a:solidFill>
+                            <a:srgbClr val="B45309"/>
+                          </a:solidFill>
+                          <a:latin typeface="Calibri"/>
+                        </a:defRPr>
+                      </a:pPr>
+                      <a:r>
+                        <a:t>Structural (Zone 2)</a:t>
+                      </a:r>
+                    </a:p>
+                  </a:txBody>
+                  <a:tcPr anchor="ctr">
+                    <a:solidFill>
+                      <a:srgbClr val="FFFFFF"/>
+                    </a:solidFill>
+                  </a:tcPr>
+                </a:tc>
+                <a:tc>
+                  <a:txBody>
+                    <a:bodyPr/>
+                    <a:lstStyle/>
+                    <a:p>
+                      <a:pPr>
+                        <a:defRPr sz="1400">
+                          <a:solidFill>
+                            <a:srgbClr val="0F172A"/>
+                          </a:solidFill>
+                          <a:latin typeface="Calibri"/>
+                        </a:defRPr>
+                      </a:pPr>
+                      <a:r>
+                        <a:t>NEW: Lifting of Truss 1 (Left Side Stage) executed without required QAQC inspections, lifting plan approval, and CSC clearance.</a:t>
+                      </a:r>
+                    </a:p>
+                  </a:txBody>
+                  <a:tcPr anchor="ctr">
+                    <a:solidFill>
+                      <a:srgbClr val="FFFFFF"/>
+                    </a:solidFill>
+                  </a:tcPr>
+                </a:tc>
+                <a:tc>
+                  <a:txBody>
+                    <a:bodyPr/>
+                    <a:lstStyle/>
+                    <a:p>
+                      <a:pPr>
+                        <a:defRPr sz="1400">
+                          <a:solidFill>
+                            <a:srgbClr val="0F172A"/>
+                          </a:solidFill>
+                          <a:latin typeface="Calibri"/>
+                        </a:defRPr>
+                      </a:pPr>
+                      <a:r>
+                        <a:t>Halt further steel erection; submit third-party rigging/lifting inspection records, connection inspection WIR, and CAPA.</a:t>
+                      </a:r>
+                    </a:p>
+                  </a:txBody>
+                  <a:tcPr anchor="ctr">
+                    <a:solidFill>
+                      <a:srgbClr val="FFFFFF"/>
+                    </a:solidFill>
+                  </a:tcPr>
+                </a:tc>
+                <a:tc>
+                  <a:txBody>
+                    <a:bodyPr/>
+                    <a:lstStyle/>
+                    <a:p>
+                      <a:pPr algn="ctr">
+                        <a:defRPr sz="1400" b="1">
+                          <a:solidFill>
+                            <a:srgbClr val="0F172A"/>
+                          </a:solidFill>
+                          <a:latin typeface="Calibri"/>
+                        </a:defRPr>
+                      </a:pPr>
+                      <a:r>
+                        <a:t>2026-09-10</a:t>
+                      </a:r>
+                    </a:p>
+                  </a:txBody>
+                  <a:tcPr anchor="ctr">
+                    <a:solidFill>
+                      <a:srgbClr val="FFFFFF"/>
+                    </a:solidFill>
+                  </a:tcPr>
+                </a:tc>
+                <a:tc>
+                  <a:txBody>
+                    <a:bodyPr/>
+                    <a:lstStyle/>
+                    <a:p>
+                      <a:pPr algn="ctr">
+                        <a:defRPr sz="2200" b="1">
+                          <a:solidFill>
+                            <a:srgbClr val="0F172A"/>
+                          </a:solidFill>
+                          <a:latin typeface="Calibri"/>
+                        </a:defRPr>
+                      </a:pPr>
+                      <a:r>
+                        <a:t>6 d</a:t>
+                      </a:r>
+                    </a:p>
+                    <a:p>
+                      <a:pPr algn="ctr">
+                        <a:defRPr sz="1200" b="1">
+                          <a:solidFill>
+                            <a:srgbClr val="64748B"/>
+                          </a:solidFill>
+                          <a:latin typeface="Calibri"/>
+                        </a:defRPr>
+                      </a:pPr>
+                      <a:r>
+                        <a:t>[&lt; 2 Months]</a:t>
+                      </a:r>
+                    </a:p>
+                  </a:txBody>
+                  <a:tcPr anchor="ctr">
+                    <a:solidFill>
+                      <a:srgbClr val="FFFFFF"/>
+                    </a:solidFill>
+                  </a:tcPr>
+                </a:tc>
+                <a:tc>
+                  <a:txBody>
+                    <a:bodyPr/>
+                    <a:lstStyle/>
+                    <a:p>
+                      <a:pPr>
+                        <a:defRPr sz="1400">
+                          <a:solidFill>
+                            <a:srgbClr val="0F172A"/>
+                          </a:solidFill>
+                          <a:latin typeface="Calibri"/>
+                        </a:defRPr>
+                      </a:pPr>
+                      <a:r>
+                        <a:rPr dirty="0"/>
+                        <a:t>Open (Awaiting CAPA) — Lifting and connection inspection records under compilation for CSC review.</a:t>
+                      </a:r>
+                    </a:p>
+                  </a:txBody>
+                  <a:tcPr anchor="ctr">
+                    <a:solidFill>
+                      <a:srgbClr val="FFFFFF"/>
+                    </a:solidFill>
+                  </a:tcPr>
+                </a:tc>
+                <a:extLst>
+                  <a:ext uri="{0D108BD9-81ED-4DB2-BD59-A6C34878D82A}">
+                    <a16:rowId xmlns:a16="http://schemas.microsoft.com/office/drawing/2014/main" val="10003"/>
                   </a:ext>
                 </a:extLst>
               </a:tr>

</xml_diff>